<commit_message>
Update 2026-OSCamp internship summary slides
</commit_message>
<xml_diff>
--- a/2026-OSCamp-实习总结汇报.pptx
+++ b/2026-OSCamp-实习总结汇报.pptx
@@ -1,6 +1,6 @@
 
 <file path=ppt/presentation.xml><?xml version="1.0" encoding="utf-8"?>
-<p:presentation xmlns:a="http://schemas.openxmlformats.org/drawingml/2006/main" xmlns:p="http://schemas.openxmlformats.org/presentationml/2006/main" xmlns:r="http://schemas.openxmlformats.org/officeDocument/2006/relationships" autoCompressPictures="0" saveSubsetFonts="1">
+<p:presentation xmlns:a="http://schemas.openxmlformats.org/drawingml/2006/main" xmlns:r="http://schemas.openxmlformats.org/officeDocument/2006/relationships" xmlns:p="http://schemas.openxmlformats.org/presentationml/2006/main" saveSubsetFonts="1" autoCompressPictures="0">
   <p:sldMasterIdLst>
     <p:sldMasterId id="2147483648" r:id="rId1"/>
   </p:sldMasterIdLst>
@@ -27,8 +27,8 @@
     <a:defPPr>
       <a:defRPr lang="en-US"/>
     </a:defPPr>
-    <a:lvl1pPr algn="l" defTabSz="457200" eaLnBrk="1" hangingPunct="1" latinLnBrk="0" marL="0" rtl="0">
-      <a:defRPr kern="1200" sz="1800">
+    <a:lvl1pPr marL="0" algn="l" defTabSz="457200" rtl="0" eaLnBrk="1" latinLnBrk="0" hangingPunct="1">
+      <a:defRPr sz="1800" kern="1200">
         <a:solidFill>
           <a:schemeClr val="tx1"/>
         </a:solidFill>
@@ -37,8 +37,8 @@
         <a:cs typeface="+mn-cs"/>
       </a:defRPr>
     </a:lvl1pPr>
-    <a:lvl2pPr algn="l" defTabSz="457200" eaLnBrk="1" hangingPunct="1" latinLnBrk="0" marL="457200" rtl="0">
-      <a:defRPr kern="1200" sz="1800">
+    <a:lvl2pPr marL="457200" algn="l" defTabSz="457200" rtl="0" eaLnBrk="1" latinLnBrk="0" hangingPunct="1">
+      <a:defRPr sz="1800" kern="1200">
         <a:solidFill>
           <a:schemeClr val="tx1"/>
         </a:solidFill>
@@ -47,8 +47,8 @@
         <a:cs typeface="+mn-cs"/>
       </a:defRPr>
     </a:lvl2pPr>
-    <a:lvl3pPr algn="l" defTabSz="457200" eaLnBrk="1" hangingPunct="1" latinLnBrk="0" marL="914400" rtl="0">
-      <a:defRPr kern="1200" sz="1800">
+    <a:lvl3pPr marL="914400" algn="l" defTabSz="457200" rtl="0" eaLnBrk="1" latinLnBrk="0" hangingPunct="1">
+      <a:defRPr sz="1800" kern="1200">
         <a:solidFill>
           <a:schemeClr val="tx1"/>
         </a:solidFill>
@@ -57,8 +57,8 @@
         <a:cs typeface="+mn-cs"/>
       </a:defRPr>
     </a:lvl3pPr>
-    <a:lvl4pPr algn="l" defTabSz="457200" eaLnBrk="1" hangingPunct="1" latinLnBrk="0" marL="1371600" rtl="0">
-      <a:defRPr kern="1200" sz="1800">
+    <a:lvl4pPr marL="1371600" algn="l" defTabSz="457200" rtl="0" eaLnBrk="1" latinLnBrk="0" hangingPunct="1">
+      <a:defRPr sz="1800" kern="1200">
         <a:solidFill>
           <a:schemeClr val="tx1"/>
         </a:solidFill>
@@ -67,8 +67,8 @@
         <a:cs typeface="+mn-cs"/>
       </a:defRPr>
     </a:lvl4pPr>
-    <a:lvl5pPr algn="l" defTabSz="457200" eaLnBrk="1" hangingPunct="1" latinLnBrk="0" marL="1828800" rtl="0">
-      <a:defRPr kern="1200" sz="1800">
+    <a:lvl5pPr marL="1828800" algn="l" defTabSz="457200" rtl="0" eaLnBrk="1" latinLnBrk="0" hangingPunct="1">
+      <a:defRPr sz="1800" kern="1200">
         <a:solidFill>
           <a:schemeClr val="tx1"/>
         </a:solidFill>
@@ -77,8 +77,8 @@
         <a:cs typeface="+mn-cs"/>
       </a:defRPr>
     </a:lvl5pPr>
-    <a:lvl6pPr algn="l" defTabSz="457200" eaLnBrk="1" hangingPunct="1" latinLnBrk="0" marL="2286000" rtl="0">
-      <a:defRPr kern="1200" sz="1800">
+    <a:lvl6pPr marL="2286000" algn="l" defTabSz="457200" rtl="0" eaLnBrk="1" latinLnBrk="0" hangingPunct="1">
+      <a:defRPr sz="1800" kern="1200">
         <a:solidFill>
           <a:schemeClr val="tx1"/>
         </a:solidFill>
@@ -87,8 +87,8 @@
         <a:cs typeface="+mn-cs"/>
       </a:defRPr>
     </a:lvl6pPr>
-    <a:lvl7pPr algn="l" defTabSz="457200" eaLnBrk="1" hangingPunct="1" latinLnBrk="0" marL="2743200" rtl="0">
-      <a:defRPr kern="1200" sz="1800">
+    <a:lvl7pPr marL="2743200" algn="l" defTabSz="457200" rtl="0" eaLnBrk="1" latinLnBrk="0" hangingPunct="1">
+      <a:defRPr sz="1800" kern="1200">
         <a:solidFill>
           <a:schemeClr val="tx1"/>
         </a:solidFill>
@@ -97,8 +97,8 @@
         <a:cs typeface="+mn-cs"/>
       </a:defRPr>
     </a:lvl7pPr>
-    <a:lvl8pPr algn="l" defTabSz="457200" eaLnBrk="1" hangingPunct="1" latinLnBrk="0" marL="3200400" rtl="0">
-      <a:defRPr kern="1200" sz="1800">
+    <a:lvl8pPr marL="3200400" algn="l" defTabSz="457200" rtl="0" eaLnBrk="1" latinLnBrk="0" hangingPunct="1">
+      <a:defRPr sz="1800" kern="1200">
         <a:solidFill>
           <a:schemeClr val="tx1"/>
         </a:solidFill>
@@ -107,8 +107,8 @@
         <a:cs typeface="+mn-cs"/>
       </a:defRPr>
     </a:lvl8pPr>
-    <a:lvl9pPr algn="l" defTabSz="457200" eaLnBrk="1" hangingPunct="1" latinLnBrk="0" marL="3657600" rtl="0">
-      <a:defRPr kern="1200" sz="1800">
+    <a:lvl9pPr marL="3657600" algn="l" defTabSz="457200" rtl="0" eaLnBrk="1" latinLnBrk="0" hangingPunct="1">
+      <a:defRPr sz="1800" kern="1200">
         <a:solidFill>
           <a:schemeClr val="tx1"/>
         </a:solidFill>
@@ -316,7 +316,7 @@
           <a:p>
             <a:fld id="{241EB5C9-1307-BA42-ABA2-0BC069CD8E7F}" type="datetimeFigureOut">
               <a:rPr lang="en-US" smtClean="0"/>
-              <a:t>1/2/22</a:t>
+              <a:t>10/2/2026</a:t>
             </a:fld>
             <a:endParaRPr lang="en-US"/>
           </a:p>
@@ -484,7 +484,7 @@
           <a:p>
             <a:fld id="{241EB5C9-1307-BA42-ABA2-0BC069CD8E7F}" type="datetimeFigureOut">
               <a:rPr lang="en-US" smtClean="0"/>
-              <a:t>1/2/22</a:t>
+              <a:t>10/2/2026</a:t>
             </a:fld>
             <a:endParaRPr lang="en-US"/>
           </a:p>
@@ -662,7 +662,7 @@
           <a:p>
             <a:fld id="{241EB5C9-1307-BA42-ABA2-0BC069CD8E7F}" type="datetimeFigureOut">
               <a:rPr lang="en-US" smtClean="0"/>
-              <a:t>1/2/22</a:t>
+              <a:t>10/2/2026</a:t>
             </a:fld>
             <a:endParaRPr lang="en-US"/>
           </a:p>
@@ -830,7 +830,7 @@
           <a:p>
             <a:fld id="{241EB5C9-1307-BA42-ABA2-0BC069CD8E7F}" type="datetimeFigureOut">
               <a:rPr lang="en-US" smtClean="0"/>
-              <a:t>1/2/22</a:t>
+              <a:t>10/2/2026</a:t>
             </a:fld>
             <a:endParaRPr lang="en-US"/>
           </a:p>
@@ -1075,7 +1075,7 @@
           <a:p>
             <a:fld id="{241EB5C9-1307-BA42-ABA2-0BC069CD8E7F}" type="datetimeFigureOut">
               <a:rPr lang="en-US" smtClean="0"/>
-              <a:t>1/2/22</a:t>
+              <a:t>10/2/2026</a:t>
             </a:fld>
             <a:endParaRPr lang="en-US"/>
           </a:p>
@@ -1360,7 +1360,7 @@
           <a:p>
             <a:fld id="{241EB5C9-1307-BA42-ABA2-0BC069CD8E7F}" type="datetimeFigureOut">
               <a:rPr lang="en-US" smtClean="0"/>
-              <a:t>1/2/22</a:t>
+              <a:t>10/2/2026</a:t>
             </a:fld>
             <a:endParaRPr lang="en-US"/>
           </a:p>
@@ -1779,7 +1779,7 @@
           <a:p>
             <a:fld id="{241EB5C9-1307-BA42-ABA2-0BC069CD8E7F}" type="datetimeFigureOut">
               <a:rPr lang="en-US" smtClean="0"/>
-              <a:t>1/2/22</a:t>
+              <a:t>10/2/2026</a:t>
             </a:fld>
             <a:endParaRPr lang="en-US"/>
           </a:p>
@@ -1896,7 +1896,7 @@
           <a:p>
             <a:fld id="{241EB5C9-1307-BA42-ABA2-0BC069CD8E7F}" type="datetimeFigureOut">
               <a:rPr lang="en-US" smtClean="0"/>
-              <a:t>1/2/22</a:t>
+              <a:t>10/2/2026</a:t>
             </a:fld>
             <a:endParaRPr lang="en-US"/>
           </a:p>
@@ -1991,7 +1991,7 @@
           <a:p>
             <a:fld id="{241EB5C9-1307-BA42-ABA2-0BC069CD8E7F}" type="datetimeFigureOut">
               <a:rPr lang="en-US" smtClean="0"/>
-              <a:t>1/2/22</a:t>
+              <a:t>10/2/2026</a:t>
             </a:fld>
             <a:endParaRPr lang="en-US"/>
           </a:p>
@@ -2266,7 +2266,7 @@
           <a:p>
             <a:fld id="{241EB5C9-1307-BA42-ABA2-0BC069CD8E7F}" type="datetimeFigureOut">
               <a:rPr lang="en-US" smtClean="0"/>
-              <a:t>1/2/22</a:t>
+              <a:t>10/2/2026</a:t>
             </a:fld>
             <a:endParaRPr lang="en-US"/>
           </a:p>
@@ -2518,7 +2518,7 @@
           <a:p>
             <a:fld id="{241EB5C9-1307-BA42-ABA2-0BC069CD8E7F}" type="datetimeFigureOut">
               <a:rPr lang="en-US" smtClean="0"/>
-              <a:t>1/2/22</a:t>
+              <a:t>10/2/2026</a:t>
             </a:fld>
             <a:endParaRPr lang="en-US"/>
           </a:p>
@@ -2580,7 +2580,7 @@
 </file>
 
 <file path=ppt/slideMasters/slideMaster1.xml><?xml version="1.0" encoding="utf-8"?>
-<p:sldMaster xmlns:a="http://schemas.openxmlformats.org/drawingml/2006/main" xmlns:p="http://schemas.openxmlformats.org/presentationml/2006/main" xmlns:r="http://schemas.openxmlformats.org/officeDocument/2006/relationships">
+<p:sldMaster xmlns:a="http://schemas.openxmlformats.org/drawingml/2006/main" xmlns:r="http://schemas.openxmlformats.org/officeDocument/2006/relationships" xmlns:p="http://schemas.openxmlformats.org/presentationml/2006/main">
   <p:cSld>
     <p:bg>
       <p:bgRef idx="1001">
@@ -2621,7 +2621,7 @@
           </a:prstGeom>
         </p:spPr>
         <p:txBody>
-          <a:bodyPr anchor="ctr" bIns="45720" lIns="91440" rIns="91440" rtlCol="0" tIns="45720" vert="horz">
+          <a:bodyPr vert="horz" lIns="91440" tIns="45720" rIns="91440" bIns="45720" rtlCol="0" anchor="ctr">
             <a:normAutofit/>
           </a:bodyPr>
           <a:lstStyle/>
@@ -2640,7 +2640,7 @@
             <a:spLocks noGrp="1"/>
           </p:cNvSpPr>
           <p:nvPr>
-            <p:ph idx="1" type="body"/>
+            <p:ph type="body" idx="1"/>
           </p:nvPr>
         </p:nvSpPr>
         <p:spPr>
@@ -2653,7 +2653,7 @@
           </a:prstGeom>
         </p:spPr>
         <p:txBody>
-          <a:bodyPr bIns="45720" lIns="91440" rIns="91440" rtlCol="0" tIns="45720" vert="horz">
+          <a:bodyPr vert="horz" lIns="91440" tIns="45720" rIns="91440" bIns="45720" rtlCol="0">
             <a:normAutofit/>
           </a:bodyPr>
           <a:lstStyle/>
@@ -2701,7 +2701,7 @@
             <a:spLocks noGrp="1"/>
           </p:cNvSpPr>
           <p:nvPr>
-            <p:ph idx="2" sz="half" type="dt"/>
+            <p:ph type="dt" sz="half" idx="2"/>
           </p:nvPr>
         </p:nvSpPr>
         <p:spPr>
@@ -2714,7 +2714,7 @@
           </a:prstGeom>
         </p:spPr>
         <p:txBody>
-          <a:bodyPr anchor="ctr" bIns="45720" lIns="91440" rIns="91440" rtlCol="0" tIns="45720" vert="horz"/>
+          <a:bodyPr vert="horz" lIns="91440" tIns="45720" rIns="91440" bIns="45720" rtlCol="0" anchor="ctr"/>
           <a:lstStyle>
             <a:lvl1pPr algn="l">
               <a:defRPr sz="900">
@@ -2729,7 +2729,7 @@
           <a:p>
             <a:fld id="{241EB5C9-1307-BA42-ABA2-0BC069CD8E7F}" type="datetimeFigureOut">
               <a:rPr lang="en-US" smtClean="0"/>
-              <a:t>1/2/22</a:t>
+              <a:t>10/2/2026</a:t>
             </a:fld>
             <a:endParaRPr lang="en-US"/>
           </a:p>
@@ -2742,7 +2742,7 @@
             <a:spLocks noGrp="1"/>
           </p:cNvSpPr>
           <p:nvPr>
-            <p:ph idx="3" sz="quarter" type="ftr"/>
+            <p:ph type="ftr" sz="quarter" idx="3"/>
           </p:nvPr>
         </p:nvSpPr>
         <p:spPr>
@@ -2755,7 +2755,7 @@
           </a:prstGeom>
         </p:spPr>
         <p:txBody>
-          <a:bodyPr anchor="ctr" bIns="45720" lIns="91440" rIns="91440" rtlCol="0" tIns="45720" vert="horz"/>
+          <a:bodyPr vert="horz" lIns="91440" tIns="45720" rIns="91440" bIns="45720" rtlCol="0" anchor="ctr"/>
           <a:lstStyle>
             <a:lvl1pPr algn="ctr">
               <a:defRPr sz="900">
@@ -2779,7 +2779,7 @@
             <a:spLocks noGrp="1"/>
           </p:cNvSpPr>
           <p:nvPr>
-            <p:ph idx="4" sz="quarter" type="sldNum"/>
+            <p:ph type="sldNum" sz="quarter" idx="4"/>
           </p:nvPr>
         </p:nvSpPr>
         <p:spPr>
@@ -2792,7 +2792,7 @@
           </a:prstGeom>
         </p:spPr>
         <p:txBody>
-          <a:bodyPr anchor="ctr" bIns="45720" lIns="91440" rIns="91440" rtlCol="0" tIns="45720" vert="horz"/>
+          <a:bodyPr vert="horz" lIns="91440" tIns="45720" rIns="91440" bIns="45720" rtlCol="0" anchor="ctr"/>
           <a:lstStyle>
             <a:lvl1pPr algn="r">
               <a:defRPr sz="900">
@@ -2820,7 +2820,7 @@
       </p:ext>
     </p:extLst>
   </p:cSld>
-  <p:clrMap accent1="accent1" accent2="accent2" accent3="accent3" accent4="accent4" accent5="accent5" accent6="accent6" bg1="lt1" bg2="lt2" folHlink="folHlink" hlink="hlink" tx1="dk1" tx2="dk2"/>
+  <p:clrMap bg1="lt1" tx1="dk1" bg2="lt2" tx2="dk2" accent1="accent1" accent2="accent2" accent3="accent3" accent4="accent4" accent5="accent5" accent6="accent6" hlink="hlink" folHlink="folHlink"/>
   <p:sldLayoutIdLst>
     <p:sldLayoutId id="2147483649" r:id="rId1"/>
     <p:sldLayoutId id="2147483650" r:id="rId2"/>
@@ -2836,12 +2836,12 @@
   </p:sldLayoutIdLst>
   <p:txStyles>
     <p:titleStyle>
-      <a:lvl1pPr algn="ctr" defTabSz="342900" eaLnBrk="1" hangingPunct="1" latinLnBrk="0" rtl="0">
+      <a:lvl1pPr algn="ctr" defTabSz="342900" rtl="0" eaLnBrk="1" latinLnBrk="0" hangingPunct="1">
         <a:spcBef>
           <a:spcPct val="0"/>
         </a:spcBef>
         <a:buNone/>
-        <a:defRPr kern="1200" sz="3300">
+        <a:defRPr sz="3300" kern="1200">
           <a:solidFill>
             <a:srgbClr val="14253D"/>
           </a:solidFill>
@@ -2852,13 +2852,13 @@
       </a:lvl1pPr>
     </p:titleStyle>
     <p:bodyStyle>
-      <a:lvl1pPr algn="l" defTabSz="342900" eaLnBrk="1" hangingPunct="1" indent="-342900" latinLnBrk="0" marL="342900" rtl="0">
+      <a:lvl1pPr marL="342900" indent="-342900" algn="l" defTabSz="342900" rtl="0" eaLnBrk="1" latinLnBrk="0" hangingPunct="1">
         <a:spcBef>
           <a:spcPct val="20000"/>
         </a:spcBef>
         <a:buFont typeface="Arial"/>
         <a:buChar char="•"/>
-        <a:defRPr kern="1200" sz="2400">
+        <a:defRPr sz="2400" kern="1200">
           <a:solidFill>
             <a:schemeClr val="tx1"/>
           </a:solidFill>
@@ -2867,13 +2867,13 @@
           <a:cs typeface="+mn-cs"/>
         </a:defRPr>
       </a:lvl1pPr>
-      <a:lvl2pPr algn="l" defTabSz="342900" eaLnBrk="1" hangingPunct="1" indent="-342900" latinLnBrk="0" marL="685800" rtl="0">
+      <a:lvl2pPr marL="685800" indent="-342900" algn="l" defTabSz="342900" rtl="0" eaLnBrk="1" latinLnBrk="0" hangingPunct="1">
         <a:spcBef>
           <a:spcPct val="20000"/>
         </a:spcBef>
         <a:buFont typeface="Arial"/>
         <a:buChar char="–"/>
-        <a:defRPr kern="1200" sz="2100">
+        <a:defRPr sz="2100" kern="1200">
           <a:solidFill>
             <a:schemeClr val="tx1"/>
           </a:solidFill>
@@ -2882,13 +2882,13 @@
           <a:cs typeface="+mn-cs"/>
         </a:defRPr>
       </a:lvl2pPr>
-      <a:lvl3pPr algn="l" defTabSz="342900" eaLnBrk="1" hangingPunct="1" indent="-342900" latinLnBrk="0" marL="1028700" rtl="0">
+      <a:lvl3pPr marL="1028700" indent="-342900" algn="l" defTabSz="342900" rtl="0" eaLnBrk="1" latinLnBrk="0" hangingPunct="1">
         <a:spcBef>
           <a:spcPct val="20000"/>
         </a:spcBef>
         <a:buFont typeface="Arial"/>
         <a:buChar char="•"/>
-        <a:defRPr kern="1200" sz="1800">
+        <a:defRPr sz="1800" kern="1200">
           <a:solidFill>
             <a:schemeClr val="tx1"/>
           </a:solidFill>
@@ -2897,13 +2897,13 @@
           <a:cs typeface="+mn-cs"/>
         </a:defRPr>
       </a:lvl3pPr>
-      <a:lvl4pPr algn="l" defTabSz="342900" eaLnBrk="1" hangingPunct="1" indent="-342900" latinLnBrk="0" marL="1371600" rtl="0">
+      <a:lvl4pPr marL="1371600" indent="-342900" algn="l" defTabSz="342900" rtl="0" eaLnBrk="1" latinLnBrk="0" hangingPunct="1">
         <a:spcBef>
           <a:spcPct val="20000"/>
         </a:spcBef>
         <a:buFont typeface="Arial"/>
         <a:buChar char="–"/>
-        <a:defRPr kern="1200" sz="1500">
+        <a:defRPr sz="1500" kern="1200">
           <a:solidFill>
             <a:schemeClr val="tx1"/>
           </a:solidFill>
@@ -2912,13 +2912,13 @@
           <a:cs typeface="+mn-cs"/>
         </a:defRPr>
       </a:lvl4pPr>
-      <a:lvl5pPr algn="l" defTabSz="342900" eaLnBrk="1" hangingPunct="1" indent="-342900" latinLnBrk="0" marL="1714500" rtl="0">
+      <a:lvl5pPr marL="1714500" indent="-342900" algn="l" defTabSz="342900" rtl="0" eaLnBrk="1" latinLnBrk="0" hangingPunct="1">
         <a:spcBef>
           <a:spcPct val="20000"/>
         </a:spcBef>
         <a:buFont typeface="Arial"/>
         <a:buChar char="»"/>
-        <a:defRPr kern="1200" sz="1500">
+        <a:defRPr sz="1500" kern="1200">
           <a:solidFill>
             <a:schemeClr val="tx1"/>
           </a:solidFill>
@@ -2927,13 +2927,13 @@
           <a:cs typeface="+mn-cs"/>
         </a:defRPr>
       </a:lvl5pPr>
-      <a:lvl6pPr algn="l" defTabSz="342900" eaLnBrk="1" hangingPunct="1" indent="-342900" latinLnBrk="0" marL="2057400" rtl="0">
+      <a:lvl6pPr marL="2057400" indent="-342900" algn="l" defTabSz="342900" rtl="0" eaLnBrk="1" latinLnBrk="0" hangingPunct="1">
         <a:spcBef>
           <a:spcPct val="20000"/>
         </a:spcBef>
         <a:buFont typeface="Arial"/>
         <a:buChar char="•"/>
-        <a:defRPr kern="1200" sz="1500">
+        <a:defRPr sz="1500" kern="1200">
           <a:solidFill>
             <a:schemeClr val="tx1"/>
           </a:solidFill>
@@ -2942,13 +2942,13 @@
           <a:cs typeface="+mn-cs"/>
         </a:defRPr>
       </a:lvl6pPr>
-      <a:lvl7pPr algn="l" defTabSz="342900" eaLnBrk="1" hangingPunct="1" indent="-342900" latinLnBrk="0" marL="2400300" rtl="0">
+      <a:lvl7pPr marL="2400300" indent="-342900" algn="l" defTabSz="342900" rtl="0" eaLnBrk="1" latinLnBrk="0" hangingPunct="1">
         <a:spcBef>
           <a:spcPct val="20000"/>
         </a:spcBef>
         <a:buFont typeface="Arial"/>
         <a:buChar char="•"/>
-        <a:defRPr kern="1200" sz="1500">
+        <a:defRPr sz="1500" kern="1200">
           <a:solidFill>
             <a:schemeClr val="tx1"/>
           </a:solidFill>
@@ -2957,13 +2957,13 @@
           <a:cs typeface="+mn-cs"/>
         </a:defRPr>
       </a:lvl7pPr>
-      <a:lvl8pPr algn="l" defTabSz="342900" eaLnBrk="1" hangingPunct="1" indent="-342900" latinLnBrk="0" marL="2743200" rtl="0">
+      <a:lvl8pPr marL="2743200" indent="-342900" algn="l" defTabSz="342900" rtl="0" eaLnBrk="1" latinLnBrk="0" hangingPunct="1">
         <a:spcBef>
           <a:spcPct val="20000"/>
         </a:spcBef>
         <a:buFont typeface="Arial"/>
         <a:buChar char="•"/>
-        <a:defRPr kern="1200" sz="1500">
+        <a:defRPr sz="1500" kern="1200">
           <a:solidFill>
             <a:schemeClr val="tx1"/>
           </a:solidFill>
@@ -2972,13 +2972,13 @@
           <a:cs typeface="+mn-cs"/>
         </a:defRPr>
       </a:lvl8pPr>
-      <a:lvl9pPr algn="l" defTabSz="342900" eaLnBrk="1" hangingPunct="1" indent="-342900" latinLnBrk="0" marL="3086100" rtl="0">
+      <a:lvl9pPr marL="3086100" indent="-342900" algn="l" defTabSz="342900" rtl="0" eaLnBrk="1" latinLnBrk="0" hangingPunct="1">
         <a:spcBef>
           <a:spcPct val="20000"/>
         </a:spcBef>
         <a:buFont typeface="Arial"/>
         <a:buChar char="•"/>
-        <a:defRPr kern="1200" sz="1500">
+        <a:defRPr sz="1500" kern="1200">
           <a:solidFill>
             <a:schemeClr val="tx1"/>
           </a:solidFill>
@@ -2992,8 +2992,8 @@
       <a:defPPr>
         <a:defRPr lang="en-US"/>
       </a:defPPr>
-      <a:lvl1pPr algn="l" defTabSz="342900" eaLnBrk="1" hangingPunct="1" latinLnBrk="0" marL="0" rtl="0">
-        <a:defRPr kern="1200" sz="1350">
+      <a:lvl1pPr marL="0" algn="l" defTabSz="342900" rtl="0" eaLnBrk="1" latinLnBrk="0" hangingPunct="1">
+        <a:defRPr sz="1350" kern="1200">
           <a:solidFill>
             <a:schemeClr val="tx1"/>
           </a:solidFill>
@@ -3002,8 +3002,8 @@
           <a:cs typeface="+mn-cs"/>
         </a:defRPr>
       </a:lvl1pPr>
-      <a:lvl2pPr algn="l" defTabSz="342900" eaLnBrk="1" hangingPunct="1" latinLnBrk="0" marL="342900" rtl="0">
-        <a:defRPr kern="1200" sz="1350">
+      <a:lvl2pPr marL="342900" algn="l" defTabSz="342900" rtl="0" eaLnBrk="1" latinLnBrk="0" hangingPunct="1">
+        <a:defRPr sz="1350" kern="1200">
           <a:solidFill>
             <a:schemeClr val="tx1"/>
           </a:solidFill>
@@ -3012,8 +3012,8 @@
           <a:cs typeface="+mn-cs"/>
         </a:defRPr>
       </a:lvl2pPr>
-      <a:lvl3pPr algn="l" defTabSz="342900" eaLnBrk="1" hangingPunct="1" latinLnBrk="0" marL="685800" rtl="0">
-        <a:defRPr kern="1200" sz="1350">
+      <a:lvl3pPr marL="685800" algn="l" defTabSz="342900" rtl="0" eaLnBrk="1" latinLnBrk="0" hangingPunct="1">
+        <a:defRPr sz="1350" kern="1200">
           <a:solidFill>
             <a:schemeClr val="tx1"/>
           </a:solidFill>
@@ -3022,8 +3022,8 @@
           <a:cs typeface="+mn-cs"/>
         </a:defRPr>
       </a:lvl3pPr>
-      <a:lvl4pPr algn="l" defTabSz="342900" eaLnBrk="1" hangingPunct="1" latinLnBrk="0" marL="1028700" rtl="0">
-        <a:defRPr kern="1200" sz="1350">
+      <a:lvl4pPr marL="1028700" algn="l" defTabSz="342900" rtl="0" eaLnBrk="1" latinLnBrk="0" hangingPunct="1">
+        <a:defRPr sz="1350" kern="1200">
           <a:solidFill>
             <a:schemeClr val="tx1"/>
           </a:solidFill>
@@ -3032,8 +3032,8 @@
           <a:cs typeface="+mn-cs"/>
         </a:defRPr>
       </a:lvl4pPr>
-      <a:lvl5pPr algn="l" defTabSz="342900" eaLnBrk="1" hangingPunct="1" latinLnBrk="0" marL="1371600" rtl="0">
-        <a:defRPr kern="1200" sz="1350">
+      <a:lvl5pPr marL="1371600" algn="l" defTabSz="342900" rtl="0" eaLnBrk="1" latinLnBrk="0" hangingPunct="1">
+        <a:defRPr sz="1350" kern="1200">
           <a:solidFill>
             <a:schemeClr val="tx1"/>
           </a:solidFill>
@@ -3042,8 +3042,8 @@
           <a:cs typeface="+mn-cs"/>
         </a:defRPr>
       </a:lvl5pPr>
-      <a:lvl6pPr algn="l" defTabSz="342900" eaLnBrk="1" hangingPunct="1" latinLnBrk="0" marL="1714500" rtl="0">
-        <a:defRPr kern="1200" sz="1350">
+      <a:lvl6pPr marL="1714500" algn="l" defTabSz="342900" rtl="0" eaLnBrk="1" latinLnBrk="0" hangingPunct="1">
+        <a:defRPr sz="1350" kern="1200">
           <a:solidFill>
             <a:schemeClr val="tx1"/>
           </a:solidFill>
@@ -3052,8 +3052,8 @@
           <a:cs typeface="+mn-cs"/>
         </a:defRPr>
       </a:lvl6pPr>
-      <a:lvl7pPr algn="l" defTabSz="342900" eaLnBrk="1" hangingPunct="1" latinLnBrk="0" marL="2057400" rtl="0">
-        <a:defRPr kern="1200" sz="1350">
+      <a:lvl7pPr marL="2057400" algn="l" defTabSz="342900" rtl="0" eaLnBrk="1" latinLnBrk="0" hangingPunct="1">
+        <a:defRPr sz="1350" kern="1200">
           <a:solidFill>
             <a:schemeClr val="tx1"/>
           </a:solidFill>
@@ -3062,8 +3062,8 @@
           <a:cs typeface="+mn-cs"/>
         </a:defRPr>
       </a:lvl7pPr>
-      <a:lvl8pPr algn="l" defTabSz="342900" eaLnBrk="1" hangingPunct="1" latinLnBrk="0" marL="2400300" rtl="0">
-        <a:defRPr kern="1200" sz="1350">
+      <a:lvl8pPr marL="2400300" algn="l" defTabSz="342900" rtl="0" eaLnBrk="1" latinLnBrk="0" hangingPunct="1">
+        <a:defRPr sz="1350" kern="1200">
           <a:solidFill>
             <a:schemeClr val="tx1"/>
           </a:solidFill>
@@ -3072,8 +3072,8 @@
           <a:cs typeface="+mn-cs"/>
         </a:defRPr>
       </a:lvl8pPr>
-      <a:lvl9pPr algn="l" defTabSz="342900" eaLnBrk="1" hangingPunct="1" latinLnBrk="0" marL="2743200" rtl="0">
-        <a:defRPr kern="1200" sz="1350">
+      <a:lvl9pPr marL="2743200" algn="l" defTabSz="342900" rtl="0" eaLnBrk="1" latinLnBrk="0" hangingPunct="1">
+        <a:defRPr sz="1350" kern="1200">
           <a:solidFill>
             <a:schemeClr val="tx1"/>
           </a:solidFill>
@@ -3121,16 +3121,80 @@
           </a:xfrm>
         </p:spPr>
         <p:txBody>
-          <a:bodyPr/>
+          <a:bodyPr>
+            <a:normAutofit fontScale="90000"/>
+          </a:bodyPr>
           <a:lstStyle/>
           <a:p>
-            <a:pPr lvl="0" indent="0" marL="0">
+            <a:pPr marL="0" lvl="0" indent="0">
               <a:buNone/>
             </a:pPr>
             <a:r>
-              <a:rPr/>
-              <a:t>2026 OSCamp 实习总结</a:t>
-            </a:r>
+              <a:rPr sz="4000" b="1" dirty="0">
+                <a:latin typeface="Times New Roman" panose="02020603050405020304" pitchFamily="18" charset="0"/>
+                <a:cs typeface="Times New Roman" panose="02020603050405020304" pitchFamily="18" charset="0"/>
+              </a:rPr>
+              <a:t>2026 </a:t>
+            </a:r>
+            <a:r>
+              <a:rPr sz="4000" b="1" dirty="0" err="1">
+                <a:latin typeface="Times New Roman" panose="02020603050405020304" pitchFamily="18" charset="0"/>
+                <a:cs typeface="Times New Roman" panose="02020603050405020304" pitchFamily="18" charset="0"/>
+              </a:rPr>
+              <a:t>实习总结</a:t>
+            </a:r>
+            <a:br>
+              <a:rPr lang="en-US" sz="4000" b="1" dirty="0">
+                <a:latin typeface="Times New Roman" panose="02020603050405020304" pitchFamily="18" charset="0"/>
+                <a:cs typeface="Times New Roman" panose="02020603050405020304" pitchFamily="18" charset="0"/>
+              </a:rPr>
+            </a:br>
+            <a:r>
+              <a:rPr lang="en-US" altLang="zh-CN" sz="3100" b="1" dirty="0" err="1">
+                <a:latin typeface="Times New Roman" panose="02020603050405020304" pitchFamily="18" charset="0"/>
+                <a:cs typeface="Times New Roman" panose="02020603050405020304" pitchFamily="18" charset="0"/>
+              </a:rPr>
+              <a:t>WiFi</a:t>
+            </a:r>
+            <a:r>
+              <a:rPr lang="en-US" altLang="zh-CN" sz="3100" b="1" dirty="0">
+                <a:latin typeface="Times New Roman" panose="02020603050405020304" pitchFamily="18" charset="0"/>
+                <a:cs typeface="Times New Roman" panose="02020603050405020304" pitchFamily="18" charset="0"/>
+              </a:rPr>
+              <a:t> </a:t>
+            </a:r>
+            <a:r>
+              <a:rPr lang="zh-CN" altLang="en-US" sz="3100" b="1" dirty="0">
+                <a:latin typeface="Times New Roman" panose="02020603050405020304" pitchFamily="18" charset="0"/>
+                <a:cs typeface="Times New Roman" panose="02020603050405020304" pitchFamily="18" charset="0"/>
+              </a:rPr>
+              <a:t>优化和 </a:t>
+            </a:r>
+            <a:r>
+              <a:rPr lang="en-US" altLang="zh-CN" sz="3100" b="1" dirty="0" err="1">
+                <a:latin typeface="Times New Roman" panose="02020603050405020304" pitchFamily="18" charset="0"/>
+                <a:cs typeface="Times New Roman" panose="02020603050405020304" pitchFamily="18" charset="0"/>
+              </a:rPr>
+              <a:t>eBPF</a:t>
+            </a:r>
+            <a:r>
+              <a:rPr lang="en-US" altLang="zh-CN" sz="3100" b="1" dirty="0">
+                <a:latin typeface="Times New Roman" panose="02020603050405020304" pitchFamily="18" charset="0"/>
+                <a:cs typeface="Times New Roman" panose="02020603050405020304" pitchFamily="18" charset="0"/>
+              </a:rPr>
+              <a:t> </a:t>
+            </a:r>
+            <a:r>
+              <a:rPr lang="zh-CN" altLang="en-US" sz="3100" b="1" dirty="0">
+                <a:latin typeface="Times New Roman" panose="02020603050405020304" pitchFamily="18" charset="0"/>
+                <a:cs typeface="Times New Roman" panose="02020603050405020304" pitchFamily="18" charset="0"/>
+              </a:rPr>
+              <a:t>网络栈可观测能力</a:t>
+            </a:r>
+            <a:endParaRPr sz="4000" b="1" dirty="0">
+              <a:latin typeface="Times New Roman" panose="02020603050405020304" pitchFamily="18" charset="0"/>
+              <a:cs typeface="Times New Roman" panose="02020603050405020304" pitchFamily="18" charset="0"/>
+            </a:endParaRPr>
           </a:p>
         </p:txBody>
       </p:sp>
@@ -3141,37 +3205,70 @@
             <a:spLocks noGrp="1"/>
           </p:cNvSpPr>
           <p:nvPr>
-            <p:ph idx="1" type="subTitle"/>
+            <p:ph type="subTitle" idx="1"/>
           </p:nvPr>
         </p:nvSpPr>
         <p:spPr>
           <a:xfrm>
-            <a:off x="1371600" y="2914650"/>
+            <a:off x="1371600" y="2571750"/>
             <a:ext cx="6400800" cy="1314450"/>
           </a:xfrm>
         </p:spPr>
         <p:txBody>
-          <a:bodyPr/>
+          <a:bodyPr>
+            <a:normAutofit/>
+          </a:bodyPr>
           <a:lstStyle/>
           <a:p>
-            <a:pPr lvl="0" indent="0" marL="0">
+            <a:pPr marL="0" lvl="0" indent="0">
               <a:buNone/>
             </a:pPr>
-            <a:r>
-              <a:rPr/>
-              <a:t>SG2002 WiFi 优化与 ax-net 网络观测</a:t>
-            </a:r>
-            <a:br/>
-            <a:br/>
-            <a:r>
-              <a:rPr/>
+            <a:br>
+              <a:rPr sz="2000" dirty="0">
+                <a:latin typeface="+mj-ea"/>
+                <a:ea typeface="+mj-ea"/>
+              </a:rPr>
+            </a:br>
+            <a:r>
+              <a:rPr sz="2000" dirty="0" err="1">
+                <a:latin typeface="+mj-ea"/>
+                <a:ea typeface="+mj-ea"/>
+              </a:rPr>
               <a:t>刘柯</a:t>
             </a:r>
+            <a:r>
+              <a:rPr lang="en-US" sz="2000" dirty="0">
+                <a:latin typeface="+mj-ea"/>
+                <a:ea typeface="+mj-ea"/>
+              </a:rPr>
+              <a:t> </a:t>
+            </a:r>
+            <a:r>
+              <a:rPr lang="en-US" altLang="zh-CN" sz="2000" dirty="0">
+                <a:latin typeface="+mj-ea"/>
+                <a:ea typeface="+mj-ea"/>
+              </a:rPr>
+              <a:t>- </a:t>
+            </a:r>
+            <a:r>
+              <a:rPr lang="en-US" altLang="zh-CN" sz="2000" dirty="0" err="1">
+                <a:latin typeface="+mj-ea"/>
+                <a:ea typeface="+mj-ea"/>
+              </a:rPr>
+              <a:t>Antareske</a:t>
+            </a:r>
+            <a:endParaRPr sz="2000" dirty="0">
+              <a:latin typeface="+mj-ea"/>
+              <a:ea typeface="+mj-ea"/>
+            </a:endParaRPr>
           </a:p>
         </p:txBody>
       </p:sp>
     </p:spTree>
   </p:cSld>
+  <p:clrMapOvr>
+    <a:masterClrMapping/>
+  </p:clrMapOvr>
 </p:sld>
 </file>
 
@@ -3207,11 +3304,10 @@
           <a:bodyPr/>
           <a:lstStyle/>
           <a:p>
-            <a:pPr lvl="0" indent="0" marL="0">
+            <a:pPr marL="0" lvl="0" indent="0">
               <a:buNone/>
             </a:pPr>
             <a:r>
-              <a:rPr/>
               <a:t>WiFi：如何确认收益来自驱动</a:t>
             </a:r>
           </a:p>
@@ -3229,74 +3325,143 @@
         </p:nvSpPr>
         <p:spPr/>
         <p:txBody>
-          <a:bodyPr/>
+          <a:bodyPr>
+            <a:noAutofit/>
+          </a:bodyPr>
           <a:lstStyle/>
           <a:p>
             <a:pPr lvl="0"/>
             <a:r>
-              <a:rPr/>
-              <a:t>相邻 WiFi 会话的板卡接收/发送曾从 </a:t>
-            </a:r>
-            <a:r>
-              <a:rPr b="1"/>
-              <a:t>15.7/2.50</a:t>
-            </a:r>
-            <a:r>
-              <a:rPr/>
-              <a:t> 变为 </a:t>
-            </a:r>
-            <a:r>
-              <a:rPr b="1"/>
-              <a:t>30.6/26.9 Mbps</a:t>
-            </a:r>
-            <a:r>
-              <a:rPr/>
-              <a:t>；跨会话吞吐不能单独用作归因。</a:t>
+              <a:rPr sz="1800" dirty="0" err="1"/>
+              <a:t>相邻</a:t>
+            </a:r>
+            <a:r>
+              <a:rPr sz="1800" dirty="0"/>
+              <a:t> </a:t>
+            </a:r>
+            <a:r>
+              <a:rPr sz="1800" dirty="0" err="1"/>
+              <a:t>WiFi</a:t>
+            </a:r>
+            <a:r>
+              <a:rPr sz="1800" dirty="0"/>
+              <a:t> </a:t>
+            </a:r>
+            <a:r>
+              <a:rPr sz="1800" dirty="0" err="1"/>
+              <a:t>会话的板卡接收</a:t>
+            </a:r>
+            <a:r>
+              <a:rPr sz="1800" dirty="0"/>
+              <a:t>/</a:t>
+            </a:r>
+            <a:r>
+              <a:rPr sz="1800" dirty="0" err="1"/>
+              <a:t>发送曾从</a:t>
+            </a:r>
+            <a:r>
+              <a:rPr sz="1800" dirty="0"/>
+              <a:t> 15.7 / 2.50 </a:t>
+            </a:r>
+            <a:r>
+              <a:rPr sz="1800" dirty="0" err="1"/>
+              <a:t>变为</a:t>
+            </a:r>
+            <a:r>
+              <a:rPr sz="1800" dirty="0"/>
+              <a:t> 30.6 / 26.9 </a:t>
+            </a:r>
+            <a:r>
+              <a:rPr sz="1800" dirty="0" err="1"/>
+              <a:t>Mbps，同一次启动内连续两轮上行也曾相差约</a:t>
+            </a:r>
+            <a:r>
+              <a:rPr sz="1800" dirty="0"/>
+              <a:t> 2.1 </a:t>
+            </a:r>
+            <a:r>
+              <a:rPr sz="1800" dirty="0" err="1"/>
+              <a:t>倍，而每笔写入字节数只差</a:t>
+            </a:r>
+            <a:r>
+              <a:rPr sz="1800" dirty="0"/>
+              <a:t> 0.5%。</a:t>
             </a:r>
           </a:p>
           <a:p>
             <a:pPr lvl="0"/>
             <a:r>
-              <a:rPr/>
-              <a:t>采用同会话 A/B/A 交替对照，并记录链路速率、信号强度和驱动机制计数。</a:t>
+              <a:rPr sz="1800" dirty="0" err="1"/>
+              <a:t>因此跨会话吞吐不能单独用作归因，改用同会话</a:t>
+            </a:r>
+            <a:r>
+              <a:rPr sz="1800" dirty="0"/>
+              <a:t> A/B/A </a:t>
+            </a:r>
+            <a:r>
+              <a:rPr sz="1800" dirty="0" err="1"/>
+              <a:t>交替对照，并记录链路速率、信号强度与驱动机制计数</a:t>
+            </a:r>
+            <a:r>
+              <a:rPr sz="1800" dirty="0"/>
+              <a:t>。</a:t>
             </a:r>
           </a:p>
           <a:p>
             <a:pPr lvl="0"/>
             <a:r>
-              <a:rPr/>
-              <a:t>放宽聚合上限后，同会话每笔写入 </a:t>
-            </a:r>
-            <a:r>
-              <a:rPr b="1"/>
-              <a:t>5,638 → 18,730 字节</a:t>
-            </a:r>
-            <a:r>
-              <a:rPr/>
-              <a:t>，单位字节成本 </a:t>
-            </a:r>
-            <a:r>
-              <a:rPr b="1"/>
-              <a:t>189 → 144 ns/B</a:t>
-            </a:r>
-            <a:r>
-              <a:rPr/>
+              <a:rPr sz="1800" dirty="0" err="1"/>
+              <a:t>放宽聚合上限后，同会话每笔写入</a:t>
+            </a:r>
+            <a:r>
+              <a:rPr sz="1800" dirty="0"/>
+              <a:t> 5638 → 18730 </a:t>
+            </a:r>
+            <a:r>
+              <a:rPr sz="1800" dirty="0" err="1"/>
+              <a:t>字节，单位字节成本</a:t>
+            </a:r>
+            <a:r>
+              <a:rPr sz="1800" dirty="0"/>
+              <a:t> 189 → 144 ns/B。</a:t>
+            </a:r>
+          </a:p>
+          <a:p>
+            <a:pPr marL="0" lvl="0" indent="0">
+              <a:buNone/>
+            </a:pPr>
+            <a:r>
+              <a:rPr sz="1800" dirty="0" err="1"/>
+              <a:t>结论：机制计数直接支持「摊薄每笔</a:t>
+            </a:r>
+            <a:r>
+              <a:rPr sz="1800" dirty="0"/>
+              <a:t> SDIO </a:t>
+            </a:r>
+            <a:r>
+              <a:rPr sz="1800" dirty="0" err="1"/>
+              <a:t>固定开销</a:t>
+            </a:r>
+            <a:r>
+              <a:rPr sz="1800" dirty="0"/>
+              <a:t>」；</a:t>
+            </a:r>
+            <a:r>
+              <a:rPr sz="1800" dirty="0" err="1"/>
+              <a:t>端到端速率仍受空口状态影响</a:t>
+            </a:r>
+            <a:r>
+              <a:rPr sz="1800" dirty="0"/>
               <a:t>。</a:t>
-            </a:r>
-          </a:p>
-          <a:p>
-            <a:pPr lvl="0" indent="0" marL="0">
-              <a:buNone/>
-            </a:pPr>
-            <a:r>
-              <a:rPr/>
-              <a:t>结论：机制计数直接支持“摊薄每笔 SDIO 固定开销”；端到端速率仍受空口状态影响。</a:t>
             </a:r>
           </a:p>
         </p:txBody>
       </p:sp>
     </p:spTree>
   </p:cSld>
+  <p:clrMapOvr>
+    <a:masterClrMapping/>
+  </p:clrMapOvr>
 </p:sld>
 </file>
 
@@ -3332,11 +3497,10 @@
           <a:bodyPr/>
           <a:lstStyle/>
           <a:p>
-            <a:pPr lvl="0" indent="0" marL="0">
+            <a:pPr marL="0" lvl="0" indent="0">
               <a:buNone/>
             </a:pPr>
             <a:r>
-              <a:rPr/>
               <a:t>ax-net：从总量到具体状态转移</a:t>
             </a:r>
           </a:p>
@@ -3344,7 +3508,7 @@
       </p:sp>
       <p:pic>
         <p:nvPicPr>
-          <p:cNvPr descr="assets/observe_layers.svg" id="0" name="Picture 1"/>
+          <p:cNvPr id="3" name="Picture 1" descr="figures/f5_observe.png"/>
           <p:cNvPicPr>
             <a:picLocks noGrp="1" noChangeAspect="1"/>
           </p:cNvPicPr>
@@ -3358,8 +3522,8 @@
         </p:blipFill>
         <p:spPr bwMode="auto">
           <a:xfrm>
-            <a:off x="508000" y="1193800"/>
-            <a:ext cx="8140700" cy="3390900"/>
+            <a:off x="457200" y="1511300"/>
+            <a:ext cx="8229600" cy="2768600"/>
           </a:xfrm>
           <a:prstGeom prst="rect">
             <a:avLst/>
@@ -3374,6 +3538,9 @@
       </p:pic>
     </p:spTree>
   </p:cSld>
+  <p:clrMapOvr>
+    <a:masterClrMapping/>
+  </p:clrMapOvr>
 </p:sld>
 </file>
 
@@ -3409,157 +3576,337 @@
           <a:bodyPr/>
           <a:lstStyle/>
           <a:p>
-            <a:pPr lvl="0" indent="0" marL="0">
+            <a:pPr marL="0" lvl="0" indent="0">
               <a:buNone/>
             </a:pPr>
             <a:r>
-              <a:rPr/>
               <a:t>ax-net：六个可复用的静态事件</a:t>
             </a:r>
           </a:p>
         </p:txBody>
       </p:sp>
-      <p:sp>
-        <p:nvSpPr>
-          <p:cNvPr id="3" name="Content Placeholder 2"/>
-          <p:cNvSpPr>
-            <a:spLocks noGrp="1"/>
-          </p:cNvSpPr>
+      <p:graphicFrame>
+        <p:nvGraphicFramePr>
+          <p:cNvPr id="6" name="Content Placeholder 5"/>
+          <p:cNvGraphicFramePr>
+            <a:graphicFrameLocks noGrp="1"/>
+          </p:cNvGraphicFramePr>
           <p:nvPr>
             <p:ph idx="1"/>
           </p:nvPr>
-        </p:nvSpPr>
-        <p:spPr/>
-        <p:txBody>
-          <a:bodyPr/>
-          <a:lstStyle/>
-          <a:p>
-            <a:pPr lvl="0"/>
-            <a:r>
-              <a:rPr b="1"/>
-              <a:t>队列推进：</a:t>
-            </a:r>
-            <a:r>
-              <a:rPr/>
-              <a:t> </a:t>
-            </a:r>
-            <a:r>
-              <a:rPr>
-                <a:latin typeface="Courier"/>
-              </a:rPr>
-              <a:t>queue_poll_round</a:t>
-            </a:r>
-            <a:r>
-              <a:rPr/>
-              <a:t> 报一轮结果；</a:t>
-            </a:r>
-            <a:r>
-              <a:rPr>
-                <a:latin typeface="Courier"/>
-              </a:rPr>
-              <a:t>queue_rearm</a:t>
-            </a:r>
-            <a:r>
-              <a:rPr/>
-              <a:t> 报重新使能未空闲的原因。</a:t>
-            </a:r>
-          </a:p>
-          <a:p>
-            <a:pPr lvl="0"/>
-            <a:r>
-              <a:rPr b="1"/>
-              <a:t>背压：</a:t>
-            </a:r>
-            <a:r>
-              <a:rPr/>
-              <a:t> </a:t>
-            </a:r>
-            <a:r>
-              <a:rPr>
-                <a:latin typeface="Courier"/>
-              </a:rPr>
-              <a:t>queue_backpressure</a:t>
-            </a:r>
-            <a:r>
-              <a:rPr/>
-              <a:t> 只报可重试的 TX 提交或 RX 补投拒绝。</a:t>
-            </a:r>
-          </a:p>
-          <a:p>
-            <a:pPr lvl="0"/>
-            <a:r>
-              <a:rPr b="1"/>
-              <a:t>帧交接：</a:t>
-            </a:r>
-            <a:r>
-              <a:rPr/>
-              <a:t> </a:t>
-            </a:r>
-            <a:r>
-              <a:rPr>
-                <a:latin typeface="Courier"/>
-              </a:rPr>
-              <a:t>tx_submit</a:t>
-            </a:r>
-            <a:r>
-              <a:rPr/>
-              <a:t> 报驱动接纳；</a:t>
-            </a:r>
-            <a:r>
-              <a:rPr>
-                <a:latin typeface="Courier"/>
-              </a:rPr>
-              <a:t>rx_publish</a:t>
-            </a:r>
-            <a:r>
-              <a:rPr/>
-              <a:t> 报协议侧队列接纳。</a:t>
-            </a:r>
-          </a:p>
-          <a:p>
-            <a:pPr lvl="0"/>
-            <a:r>
-              <a:rPr b="1"/>
-              <a:t>协议执行：</a:t>
-            </a:r>
-            <a:r>
-              <a:rPr/>
-              <a:t> </a:t>
-            </a:r>
-            <a:r>
-              <a:rPr>
-                <a:latin typeface="Courier"/>
-              </a:rPr>
-              <a:t>proto_yield</a:t>
-            </a:r>
-            <a:r>
-              <a:rPr/>
-              <a:t> 报预算耗尽后的让出及是否仍有待办。</a:t>
-            </a:r>
-          </a:p>
-          <a:p>
-            <a:pPr lvl="0" indent="0" marL="0">
-              <a:buNone/>
-            </a:pPr>
-            <a:r>
-              <a:rPr/>
-              <a:t>五个队列事件携带同一队列身份；</a:t>
-            </a:r>
-            <a:r>
-              <a:rPr>
-                <a:latin typeface="Courier"/>
-              </a:rPr>
-              <a:t>work_units</a:t>
-            </a:r>
-            <a:r>
-              <a:rPr/>
-              <a:t> 是执行器工作单位，不是包数。</a:t>
-            </a:r>
-          </a:p>
-        </p:txBody>
-      </p:sp>
+        </p:nvGraphicFramePr>
+        <p:xfrm>
+          <a:off x="457200" y="1193800"/>
+          <a:ext cx="8229600" cy="2903220"/>
+        </p:xfrm>
+        <a:graphic>
+          <a:graphicData uri="http://schemas.openxmlformats.org/drawingml/2006/table">
+            <a:tbl>
+              <a:tblPr firstRow="1" bandRow="1">
+                <a:tableStyleId>{5C22544A-7EE6-4342-B048-85BDC9FD1C3A}</a:tableStyleId>
+              </a:tblPr>
+              <a:tblGrid>
+                <a:gridCol w="4114800">
+                  <a:extLst>
+                    <a:ext uri="{9D8B030D-6E8A-4147-A177-3AD203B41FA5}">
+                      <a16:colId xmlns:a16="http://schemas.microsoft.com/office/drawing/2014/main" val="20000"/>
+                    </a:ext>
+                  </a:extLst>
+                </a:gridCol>
+                <a:gridCol w="4114800">
+                  <a:extLst>
+                    <a:ext uri="{9D8B030D-6E8A-4147-A177-3AD203B41FA5}">
+                      <a16:colId xmlns:a16="http://schemas.microsoft.com/office/drawing/2014/main" val="20001"/>
+                    </a:ext>
+                  </a:extLst>
+                </a:gridCol>
+              </a:tblGrid>
+              <a:tr h="0">
+                <a:tc>
+                  <a:txBody>
+                    <a:bodyPr/>
+                    <a:lstStyle/>
+                    <a:p>
+                      <a:pPr marL="0" lvl="0" indent="0">
+                        <a:buNone/>
+                      </a:pPr>
+                      <a:r>
+                        <a:t>事件</a:t>
+                      </a:r>
+                    </a:p>
+                  </a:txBody>
+                  <a:tcPr/>
+                </a:tc>
+                <a:tc>
+                  <a:txBody>
+                    <a:bodyPr/>
+                    <a:lstStyle/>
+                    <a:p>
+                      <a:pPr marL="0" lvl="0" indent="0">
+                        <a:buNone/>
+                      </a:pPr>
+                      <a:r>
+                        <a:t>边界含义</a:t>
+                      </a:r>
+                    </a:p>
+                  </a:txBody>
+                  <a:tcPr/>
+                </a:tc>
+                <a:extLst>
+                  <a:ext uri="{0D108BD9-81ED-4DB2-BD59-A6C34878D82A}">
+                    <a16:rowId xmlns:a16="http://schemas.microsoft.com/office/drawing/2014/main" val="10000"/>
+                  </a:ext>
+                </a:extLst>
+              </a:tr>
+              <a:tr h="0">
+                <a:tc>
+                  <a:txBody>
+                    <a:bodyPr/>
+                    <a:lstStyle/>
+                    <a:p>
+                      <a:pPr marL="0" lvl="0" indent="0">
+                        <a:buNone/>
+                      </a:pPr>
+                      <a:r>
+                        <a:rPr>
+                          <a:latin typeface="Courier"/>
+                        </a:rPr>
+                        <a:t>queue_poll_round</a:t>
+                      </a:r>
+                    </a:p>
+                  </a:txBody>
+                  <a:tcPr/>
+                </a:tc>
+                <a:tc>
+                  <a:txBody>
+                    <a:bodyPr/>
+                    <a:lstStyle/>
+                    <a:p>
+                      <a:pPr marL="0" lvl="0" indent="0">
+                        <a:buNone/>
+                      </a:pPr>
+                      <a:r>
+                        <a:t>一次轮询调用返回时报告队列身份、预算、工作单位与结果；工作单位不是包数</a:t>
+                      </a:r>
+                    </a:p>
+                  </a:txBody>
+                  <a:tcPr/>
+                </a:tc>
+                <a:extLst>
+                  <a:ext uri="{0D108BD9-81ED-4DB2-BD59-A6C34878D82A}">
+                    <a16:rowId xmlns:a16="http://schemas.microsoft.com/office/drawing/2014/main" val="10001"/>
+                  </a:ext>
+                </a:extLst>
+              </a:tr>
+              <a:tr h="0">
+                <a:tc>
+                  <a:txBody>
+                    <a:bodyPr/>
+                    <a:lstStyle/>
+                    <a:p>
+                      <a:pPr marL="0" lvl="0" indent="0">
+                        <a:buNone/>
+                      </a:pPr>
+                      <a:r>
+                        <a:rPr>
+                          <a:latin typeface="Courier"/>
+                        </a:rPr>
+                        <a:t>queue_rearm</a:t>
+                      </a:r>
+                    </a:p>
+                  </a:txBody>
+                  <a:tcPr/>
+                </a:tc>
+                <a:tc>
+                  <a:txBody>
+                    <a:bodyPr/>
+                    <a:lstStyle/>
+                    <a:p>
+                      <a:pPr marL="0" lvl="0" indent="0">
+                        <a:buNone/>
+                      </a:pPr>
+                      <a:r>
+                        <a:t>重新使能未以正常空闲结束时报告竞态、仍有工作、延迟重试或失败</a:t>
+                      </a:r>
+                    </a:p>
+                  </a:txBody>
+                  <a:tcPr/>
+                </a:tc>
+                <a:extLst>
+                  <a:ext uri="{0D108BD9-81ED-4DB2-BD59-A6C34878D82A}">
+                    <a16:rowId xmlns:a16="http://schemas.microsoft.com/office/drawing/2014/main" val="10002"/>
+                  </a:ext>
+                </a:extLst>
+              </a:tr>
+              <a:tr h="0">
+                <a:tc>
+                  <a:txBody>
+                    <a:bodyPr/>
+                    <a:lstStyle/>
+                    <a:p>
+                      <a:pPr marL="0" lvl="0" indent="0">
+                        <a:buNone/>
+                      </a:pPr>
+                      <a:r>
+                        <a:rPr>
+                          <a:latin typeface="Courier"/>
+                        </a:rPr>
+                        <a:t>queue_backpressure</a:t>
+                      </a:r>
+                    </a:p>
+                  </a:txBody>
+                  <a:tcPr/>
+                </a:tc>
+                <a:tc>
+                  <a:txBody>
+                    <a:bodyPr/>
+                    <a:lstStyle/>
+                    <a:p>
+                      <a:pPr marL="0" lvl="0" indent="0">
+                        <a:buNone/>
+                      </a:pPr>
+                      <a:r>
+                        <a:t>设备明确拒绝可重试的 TX 提交或 RX 补投时报告位置与原因</a:t>
+                      </a:r>
+                    </a:p>
+                  </a:txBody>
+                  <a:tcPr/>
+                </a:tc>
+                <a:extLst>
+                  <a:ext uri="{0D108BD9-81ED-4DB2-BD59-A6C34878D82A}">
+                    <a16:rowId xmlns:a16="http://schemas.microsoft.com/office/drawing/2014/main" val="10003"/>
+                  </a:ext>
+                </a:extLst>
+              </a:tr>
+              <a:tr h="0">
+                <a:tc>
+                  <a:txBody>
+                    <a:bodyPr/>
+                    <a:lstStyle/>
+                    <a:p>
+                      <a:pPr marL="0" lvl="0" indent="0">
+                        <a:buNone/>
+                      </a:pPr>
+                      <a:r>
+                        <a:rPr>
+                          <a:latin typeface="Courier"/>
+                        </a:rPr>
+                        <a:t>tx_submit</a:t>
+                      </a:r>
+                    </a:p>
+                  </a:txBody>
+                  <a:tcPr/>
+                </a:tc>
+                <a:tc>
+                  <a:txBody>
+                    <a:bodyPr/>
+                    <a:lstStyle/>
+                    <a:p>
+                      <a:pPr marL="0" lvl="0" indent="0">
+                        <a:buNone/>
+                      </a:pPr>
+                      <a:r>
+                        <a:t>驱动接纳一帧；接纳不等于硬件已发出</a:t>
+                      </a:r>
+                    </a:p>
+                  </a:txBody>
+                  <a:tcPr/>
+                </a:tc>
+                <a:extLst>
+                  <a:ext uri="{0D108BD9-81ED-4DB2-BD59-A6C34878D82A}">
+                    <a16:rowId xmlns:a16="http://schemas.microsoft.com/office/drawing/2014/main" val="10004"/>
+                  </a:ext>
+                </a:extLst>
+              </a:tr>
+              <a:tr h="0">
+                <a:tc>
+                  <a:txBody>
+                    <a:bodyPr/>
+                    <a:lstStyle/>
+                    <a:p>
+                      <a:pPr marL="0" lvl="0" indent="0">
+                        <a:buNone/>
+                      </a:pPr>
+                      <a:r>
+                        <a:rPr>
+                          <a:latin typeface="Courier"/>
+                        </a:rPr>
+                        <a:t>rx_publish</a:t>
+                      </a:r>
+                    </a:p>
+                  </a:txBody>
+                  <a:tcPr/>
+                </a:tc>
+                <a:tc>
+                  <a:txBody>
+                    <a:bodyPr/>
+                    <a:lstStyle/>
+                    <a:p>
+                      <a:pPr marL="0" lvl="0" indent="0">
+                        <a:buNone/>
+                      </a:pPr>
+                      <a:r>
+                        <a:t>帧进入协议侧队列；发布不等于协议栈已处理</a:t>
+                      </a:r>
+                    </a:p>
+                  </a:txBody>
+                  <a:tcPr/>
+                </a:tc>
+                <a:extLst>
+                  <a:ext uri="{0D108BD9-81ED-4DB2-BD59-A6C34878D82A}">
+                    <a16:rowId xmlns:a16="http://schemas.microsoft.com/office/drawing/2014/main" val="10005"/>
+                  </a:ext>
+                </a:extLst>
+              </a:tr>
+              <a:tr h="0">
+                <a:tc>
+                  <a:txBody>
+                    <a:bodyPr/>
+                    <a:lstStyle/>
+                    <a:p>
+                      <a:pPr marL="0" lvl="0" indent="0">
+                        <a:buNone/>
+                      </a:pPr>
+                      <a:r>
+                        <a:rPr>
+                          <a:latin typeface="Courier"/>
+                        </a:rPr>
+                        <a:t>proto_yield</a:t>
+                      </a:r>
+                    </a:p>
+                  </a:txBody>
+                  <a:tcPr/>
+                </a:tc>
+                <a:tc>
+                  <a:txBody>
+                    <a:bodyPr/>
+                    <a:lstStyle/>
+                    <a:p>
+                      <a:pPr marL="0" lvl="0" indent="0">
+                        <a:buNone/>
+                      </a:pPr>
+                      <a:r>
+                        <a:t>协议执行器因轮询次数或时间预算耗尽而让出，并记录是否仍有待办</a:t>
+                      </a:r>
+                    </a:p>
+                  </a:txBody>
+                  <a:tcPr/>
+                </a:tc>
+                <a:extLst>
+                  <a:ext uri="{0D108BD9-81ED-4DB2-BD59-A6C34878D82A}">
+                    <a16:rowId xmlns:a16="http://schemas.microsoft.com/office/drawing/2014/main" val="10006"/>
+                  </a:ext>
+                </a:extLst>
+              </a:tr>
+            </a:tbl>
+          </a:graphicData>
+        </a:graphic>
+      </p:graphicFrame>
     </p:spTree>
   </p:cSld>
+  <p:clrMapOvr>
+    <a:masterClrMapping/>
+  </p:clrMapOvr>
 </p:sld>
 </file>
 
@@ -3595,11 +3942,10 @@
           <a:bodyPr/>
           <a:lstStyle/>
           <a:p>
-            <a:pPr lvl="0" indent="0" marL="0">
+            <a:pPr marL="0" lvl="0" indent="0">
               <a:buNone/>
             </a:pPr>
             <a:r>
-              <a:rPr/>
               <a:t>eBPF：消费事件与失败隔离</a:t>
             </a:r>
           </a:p>
@@ -3617,76 +3963,194 @@
         </p:nvSpPr>
         <p:spPr/>
         <p:txBody>
-          <a:bodyPr/>
+          <a:bodyPr>
+            <a:noAutofit/>
+          </a:bodyPr>
           <a:lstStyle/>
           <a:p>
             <a:pPr lvl="0"/>
             <a:r>
-              <a:rPr>
+              <a:rPr sz="1800" dirty="0" err="1">
                 <a:latin typeface="Courier"/>
               </a:rPr>
               <a:t>net_queue_poll</a:t>
             </a:r>
             <a:r>
-              <a:rPr/>
-              <a:t> 示例附着 </a:t>
-            </a:r>
-            <a:r>
-              <a:rPr>
+              <a:rPr sz="1800" dirty="0"/>
+              <a:t> </a:t>
+            </a:r>
+            <a:r>
+              <a:rPr sz="1800" dirty="0" err="1"/>
+              <a:t>示例附着</a:t>
+            </a:r>
+            <a:r>
+              <a:rPr sz="1800" dirty="0"/>
+              <a:t> </a:t>
+            </a:r>
+            <a:r>
+              <a:rPr sz="1800" dirty="0" err="1">
                 <a:latin typeface="Courier"/>
               </a:rPr>
               <a:t>net:queue_poll_round</a:t>
             </a:r>
             <a:r>
-              <a:rPr/>
-              <a:t>，演示 </a:t>
-            </a:r>
-            <a:r>
-              <a:rPr b="1"/>
-              <a:t>load → attach → enable → read</a:t>
-            </a:r>
-            <a:r>
-              <a:rPr/>
+              <a:rPr sz="1800" dirty="0" err="1"/>
+              <a:t>，演示</a:t>
+            </a:r>
+            <a:r>
+              <a:rPr sz="1800" dirty="0"/>
+              <a:t> </a:t>
+            </a:r>
+            <a:r>
+              <a:rPr sz="1800" b="1" dirty="0"/>
+              <a:t>load → attach → enable → </a:t>
+            </a:r>
+            <a:r>
+              <a:rPr sz="1800" b="1" dirty="0" err="1"/>
+              <a:t>read</a:t>
+            </a:r>
+            <a:r>
+              <a:rPr sz="1800" dirty="0" err="1"/>
+              <a:t>；它只证明消费链路连通，不定义事件语义</a:t>
+            </a:r>
+            <a:r>
+              <a:rPr sz="1800" dirty="0"/>
               <a:t>。</a:t>
             </a:r>
           </a:p>
           <a:p>
             <a:pPr lvl="0"/>
             <a:r>
-              <a:rPr/>
-              <a:t>静态 tracepoint 避开 Rust 函数内联与符号变化对动态探针的影响；事件名和字段成为维护契约。</a:t>
-            </a:r>
-          </a:p>
-          <a:p>
-            <a:pPr lvl="0"/>
-            <a:r>
-              <a:rPr/>
-              <a:t>故障探针防护：内核拷贝使用 nofault 恢复路径；坏地址返回 </a:t>
-            </a:r>
-            <a:r>
-              <a:rPr>
+              <a:rPr sz="1800" dirty="0" err="1"/>
+              <a:t>选择静态</a:t>
+            </a:r>
+            <a:r>
+              <a:rPr sz="1800" dirty="0"/>
+              <a:t> </a:t>
+            </a:r>
+            <a:r>
+              <a:rPr sz="1800" dirty="0" err="1"/>
+              <a:t>tracepoint</a:t>
+            </a:r>
+            <a:r>
+              <a:rPr sz="1800" dirty="0"/>
+              <a:t> </a:t>
+            </a:r>
+            <a:r>
+              <a:rPr sz="1800" dirty="0" err="1"/>
+              <a:t>而非动态函数探针：Rust</a:t>
+            </a:r>
+            <a:r>
+              <a:rPr sz="1800" dirty="0"/>
+              <a:t> </a:t>
+            </a:r>
+            <a:r>
+              <a:rPr sz="1800" dirty="0" err="1"/>
+              <a:t>内联会让符号消去或变私有，为保住探针符号给热路径加</a:t>
+            </a:r>
+            <a:r>
+              <a:rPr sz="1800" dirty="0"/>
+              <a:t> </a:t>
+            </a:r>
+            <a:r>
+              <a:rPr sz="1800" dirty="0">
                 <a:latin typeface="Courier"/>
               </a:rPr>
-              <a:t>-EFAULT</a:t>
-            </a:r>
-            <a:r>
-              <a:rPr/>
-              <a:t>，畸形指令流在加载期拒绝，挂点注册失败返回错误。</a:t>
-            </a:r>
-          </a:p>
-          <a:p>
-            <a:pPr lvl="0" indent="0" marL="0">
-              <a:buNone/>
-            </a:pPr>
-            <a:r>
-              <a:rPr/>
-              <a:t>示例程序证明消费链路连通；事件语义由网络栈测试验证。</a:t>
+              <a:t>#[inline(never)]</a:t>
+            </a:r>
+            <a:r>
+              <a:rPr sz="1800" dirty="0"/>
+              <a:t> </a:t>
+            </a:r>
+            <a:r>
+              <a:rPr sz="1800" dirty="0" err="1"/>
+              <a:t>会永久改变热路径。事件按数值</a:t>
+            </a:r>
+            <a:r>
+              <a:rPr sz="1800" dirty="0"/>
+              <a:t> id </a:t>
+            </a:r>
+            <a:r>
+              <a:rPr sz="1800" dirty="0" err="1"/>
+              <a:t>附着，事件名与字段构成面向用户的维护契约</a:t>
+            </a:r>
+            <a:r>
+              <a:rPr sz="1800" dirty="0"/>
+              <a:t>。</a:t>
+            </a:r>
+          </a:p>
+          <a:p>
+            <a:pPr lvl="0"/>
+            <a:r>
+              <a:rPr sz="1800" dirty="0" err="1"/>
+              <a:t>故障探针防护：内核拷贝走</a:t>
+            </a:r>
+            <a:r>
+              <a:rPr sz="1800" dirty="0"/>
+              <a:t> </a:t>
+            </a:r>
+            <a:r>
+              <a:rPr sz="1800" dirty="0" err="1"/>
+              <a:t>nofault</a:t>
+            </a:r>
+            <a:r>
+              <a:rPr sz="1800" dirty="0"/>
+              <a:t> </a:t>
+            </a:r>
+            <a:r>
+              <a:rPr sz="1800" dirty="0" err="1"/>
+              <a:t>恢复路径，坏地址返回</a:t>
+            </a:r>
+            <a:r>
+              <a:rPr sz="1800" dirty="0"/>
+              <a:t> </a:t>
+            </a:r>
+            <a:r>
+              <a:rPr sz="1800" dirty="0">
+                <a:latin typeface="Courier"/>
+              </a:rPr>
+              <a:t>-</a:t>
+            </a:r>
+            <a:r>
+              <a:rPr sz="1800" dirty="0" err="1">
+                <a:latin typeface="Courier"/>
+              </a:rPr>
+              <a:t>EFAULT</a:t>
+            </a:r>
+            <a:r>
+              <a:rPr sz="1800" dirty="0" err="1"/>
+              <a:t>；畸形指令流在加载期以</a:t>
+            </a:r>
+            <a:r>
+              <a:rPr sz="1800" dirty="0"/>
+              <a:t> </a:t>
+            </a:r>
+            <a:r>
+              <a:rPr sz="1800" dirty="0">
+                <a:latin typeface="Courier"/>
+              </a:rPr>
+              <a:t>EINVAL</a:t>
+            </a:r>
+            <a:r>
+              <a:rPr sz="1800" dirty="0"/>
+              <a:t> </a:t>
+            </a:r>
+            <a:r>
+              <a:rPr sz="1800" dirty="0" err="1"/>
+              <a:t>拒绝；挂点注册失败返回错误而非</a:t>
+            </a:r>
+            <a:r>
+              <a:rPr sz="1800" dirty="0"/>
+              <a:t> panic。</a:t>
             </a:r>
           </a:p>
         </p:txBody>
       </p:sp>
     </p:spTree>
   </p:cSld>
+  <p:clrMapOvr>
+    <a:masterClrMapping/>
+  </p:clrMapOvr>
 </p:sld>
 </file>
 
@@ -3722,11 +4186,10 @@
           <a:bodyPr/>
           <a:lstStyle/>
           <a:p>
-            <a:pPr lvl="0" indent="0" marL="0">
+            <a:pPr marL="0" lvl="0" indent="0">
               <a:buNone/>
             </a:pPr>
             <a:r>
-              <a:rPr/>
               <a:t>验证结果与边界</a:t>
             </a:r>
           </a:p>
@@ -3744,7 +4207,7 @@
         </p:nvGraphicFramePr>
         <p:xfrm>
           <a:off x="457200" y="1193800"/>
-          <a:ext cx="8229600" cy="3390900"/>
+          <a:ext cx="8229600" cy="2400300"/>
         </p:xfrm>
         <a:graphic>
           <a:graphicData uri="http://schemas.openxmlformats.org/drawingml/2006/table">
@@ -3753,8 +4216,20 @@
                 <a:tableStyleId>{5C22544A-7EE6-4342-B048-85BDC9FD1C3A}</a:tableStyleId>
               </a:tblPr>
               <a:tblGrid>
-                <a:gridCol w="4114800"/>
-                <a:gridCol w="4114800"/>
+                <a:gridCol w="4114800">
+                  <a:extLst>
+                    <a:ext uri="{9D8B030D-6E8A-4147-A177-3AD203B41FA5}">
+                      <a16:colId xmlns:a16="http://schemas.microsoft.com/office/drawing/2014/main" val="20000"/>
+                    </a:ext>
+                  </a:extLst>
+                </a:gridCol>
+                <a:gridCol w="4114800">
+                  <a:extLst>
+                    <a:ext uri="{9D8B030D-6E8A-4147-A177-3AD203B41FA5}">
+                      <a16:colId xmlns:a16="http://schemas.microsoft.com/office/drawing/2014/main" val="20001"/>
+                    </a:ext>
+                  </a:extLst>
+                </a:gridCol>
               </a:tblGrid>
               <a:tr h="0">
                 <a:tc>
@@ -3762,11 +4237,10 @@
                     <a:bodyPr/>
                     <a:lstStyle/>
                     <a:p>
-                      <a:pPr lvl="0" indent="0" marL="0">
+                      <a:pPr marL="0" lvl="0" indent="0">
                         <a:buNone/>
                       </a:pPr>
                       <a:r>
-                        <a:rPr/>
                         <a:t>验证</a:t>
                       </a:r>
                     </a:p>
@@ -3778,17 +4252,21 @@
                     <a:bodyPr/>
                     <a:lstStyle/>
                     <a:p>
-                      <a:pPr lvl="0" indent="0" marL="0">
+                      <a:pPr marL="0" lvl="0" indent="0">
                         <a:buNone/>
                       </a:pPr>
                       <a:r>
-                        <a:rPr/>
                         <a:t>结果</a:t>
                       </a:r>
                     </a:p>
                   </a:txBody>
                   <a:tcPr/>
                 </a:tc>
+                <a:extLst>
+                  <a:ext uri="{0D108BD9-81ED-4DB2-BD59-A6C34878D82A}">
+                    <a16:rowId xmlns:a16="http://schemas.microsoft.com/office/drawing/2014/main" val="10000"/>
+                  </a:ext>
+                </a:extLst>
               </a:tr>
               <a:tr h="0">
                 <a:tc>
@@ -3796,31 +4274,36 @@
                     <a:bodyPr/>
                     <a:lstStyle/>
                     <a:p>
-                      <a:pPr lvl="0" indent="0" marL="0">
+                      <a:pPr marL="0" lvl="0" indent="0">
                         <a:buNone/>
                       </a:pPr>
                       <a:r>
-                        <a:rPr/>
                         <a:t>ax-net 单元测试</a:t>
                       </a:r>
                     </a:p>
                   </a:txBody>
+                  <a:tcPr/>
                 </a:tc>
                 <a:tc>
                   <a:txBody>
                     <a:bodyPr/>
                     <a:lstStyle/>
                     <a:p>
-                      <a:pPr lvl="0" indent="0" marL="0">
+                      <a:pPr marL="0" lvl="0" indent="0">
                         <a:buNone/>
                       </a:pPr>
                       <a:r>
-                        <a:rPr/>
-                        <a:t>149 项通过，覆盖事件触发与队列状态边界</a:t>
+                        <a:t>149 项通过，覆盖事件触发次数、轮询结果不变与背压边界</a:t>
                       </a:r>
                     </a:p>
                   </a:txBody>
+                  <a:tcPr/>
                 </a:tc>
+                <a:extLst>
+                  <a:ext uri="{0D108BD9-81ED-4DB2-BD59-A6C34878D82A}">
+                    <a16:rowId xmlns:a16="http://schemas.microsoft.com/office/drawing/2014/main" val="10001"/>
+                  </a:ext>
+                </a:extLst>
               </a:tr>
               <a:tr h="0">
                 <a:tc>
@@ -3828,31 +4311,36 @@
                     <a:bodyPr/>
                     <a:lstStyle/>
                     <a:p>
-                      <a:pPr lvl="0" indent="0" marL="0">
+                      <a:pPr marL="0" lvl="0" indent="0">
                         <a:buNone/>
                       </a:pPr>
                       <a:r>
-                        <a:rPr/>
-                        <a:t>QEMU 队列快照与事件</a:t>
+                        <a:t>队列快照 QEMU 测试</a:t>
                       </a:r>
                     </a:p>
                   </a:txBody>
+                  <a:tcPr/>
                 </a:tc>
                 <a:tc>
                   <a:txBody>
                     <a:bodyPr/>
                     <a:lstStyle/>
                     <a:p>
-                      <a:pPr lvl="0" indent="0" marL="0">
+                      <a:pPr marL="0" lvl="0" indent="0">
                         <a:buNone/>
                       </a:pPr>
                       <a:r>
-                        <a:rPr/>
-                        <a:t>四种配置通过；真实流量读到轮询、帧交接与协议让出</a:t>
+                        <a:t>四种配置均读到 1 个接口、1 个队列组，字段与归属 CPU 已校验</a:t>
                       </a:r>
                     </a:p>
                   </a:txBody>
+                  <a:tcPr/>
                 </a:tc>
+                <a:extLst>
+                  <a:ext uri="{0D108BD9-81ED-4DB2-BD59-A6C34878D82A}">
+                    <a16:rowId xmlns:a16="http://schemas.microsoft.com/office/drawing/2014/main" val="10002"/>
+                  </a:ext>
+                </a:extLst>
               </a:tr>
               <a:tr h="0">
                 <a:tc>
@@ -3860,31 +4348,36 @@
                     <a:bodyPr/>
                     <a:lstStyle/>
                     <a:p>
-                      <a:pPr lvl="0" indent="0" marL="0">
+                      <a:pPr marL="0" lvl="0" indent="0">
                         <a:buNone/>
                       </a:pPr>
                       <a:r>
-                        <a:rPr/>
-                        <a:t>eBPF 冒烟</a:t>
+                        <a:t>网络事件 QEMU 测试</a:t>
                       </a:r>
                     </a:p>
                   </a:txBody>
+                  <a:tcPr/>
                 </a:tc>
                 <a:tc>
                   <a:txBody>
                     <a:bodyPr/>
                     <a:lstStyle/>
                     <a:p>
-                      <a:pPr lvl="0" indent="0" marL="0">
+                      <a:pPr marL="0" lvl="0" indent="0">
                         <a:buNone/>
                       </a:pPr>
                       <a:r>
-                        <a:rPr/>
-                        <a:t>四架构读回记录；加载、附着、启用、读取链路连通</a:t>
+                        <a:t>四种配置通过；真实流量读到轮询、发送接纳、接收发布与协议让出，关闭后不再产出</a:t>
                       </a:r>
                     </a:p>
                   </a:txBody>
+                  <a:tcPr/>
                 </a:tc>
+                <a:extLst>
+                  <a:ext uri="{0D108BD9-81ED-4DB2-BD59-A6C34878D82A}">
+                    <a16:rowId xmlns:a16="http://schemas.microsoft.com/office/drawing/2014/main" val="10003"/>
+                  </a:ext>
+                </a:extLst>
               </a:tr>
               <a:tr h="0">
                 <a:tc>
@@ -3892,31 +4385,73 @@
                     <a:bodyPr/>
                     <a:lstStyle/>
                     <a:p>
-                      <a:pPr lvl="0" indent="0" marL="0">
+                      <a:pPr marL="0" lvl="0" indent="0">
                         <a:buNone/>
                       </a:pPr>
                       <a:r>
-                        <a:rPr/>
-                        <a:t>静态检查</a:t>
+                        <a:t>eBPF 附着测试</a:t>
                       </a:r>
                     </a:p>
                   </a:txBody>
+                  <a:tcPr/>
                 </a:tc>
                 <a:tc>
                   <a:txBody>
                     <a:bodyPr/>
                     <a:lstStyle/>
                     <a:p>
-                      <a:pPr lvl="0" indent="0" marL="0">
+                      <a:pPr marL="0" lvl="0" indent="0">
                         <a:buNone/>
                       </a:pPr>
                       <a:r>
-                        <a:rPr/>
-                        <a:t>ax-net 9 项、StarryOS 内核 80 项组合通过</a:t>
+                        <a:t>四架构回归分别读回 5/5/7/5 条记录</a:t>
                       </a:r>
                     </a:p>
                   </a:txBody>
+                  <a:tcPr/>
                 </a:tc>
+                <a:extLst>
+                  <a:ext uri="{0D108BD9-81ED-4DB2-BD59-A6C34878D82A}">
+                    <a16:rowId xmlns:a16="http://schemas.microsoft.com/office/drawing/2014/main" val="10004"/>
+                  </a:ext>
+                </a:extLst>
+              </a:tr>
+              <a:tr h="0">
+                <a:tc>
+                  <a:txBody>
+                    <a:bodyPr/>
+                    <a:lstStyle/>
+                    <a:p>
+                      <a:pPr marL="0" lvl="0" indent="0">
+                        <a:buNone/>
+                      </a:pPr>
+                      <a:r>
+                        <a:t>静态检查</a:t>
+                      </a:r>
+                    </a:p>
+                  </a:txBody>
+                  <a:tcPr/>
+                </a:tc>
+                <a:tc>
+                  <a:txBody>
+                    <a:bodyPr/>
+                    <a:lstStyle/>
+                    <a:p>
+                      <a:pPr marL="0" lvl="0" indent="0">
+                        <a:buNone/>
+                      </a:pPr>
+                      <a:r>
+                        <a:t>ax-net 9 项、StarryOS 内核 80 项 Clippy 组合通过</a:t>
+                      </a:r>
+                    </a:p>
+                  </a:txBody>
+                  <a:tcPr/>
+                </a:tc>
+                <a:extLst>
+                  <a:ext uri="{0D108BD9-81ED-4DB2-BD59-A6C34878D82A}">
+                    <a16:rowId xmlns:a16="http://schemas.microsoft.com/office/drawing/2014/main" val="10005"/>
+                  </a:ext>
+                </a:extLst>
               </a:tr>
             </a:tbl>
           </a:graphicData>
@@ -3924,6 +4459,9 @@
       </p:graphicFrame>
     </p:spTree>
   </p:cSld>
+  <p:clrMapOvr>
+    <a:masterClrMapping/>
+  </p:clrMapOvr>
 </p:sld>
 </file>
 
@@ -3959,11 +4497,10 @@
           <a:bodyPr/>
           <a:lstStyle/>
           <a:p>
-            <a:pPr lvl="0" indent="0" marL="0">
+            <a:pPr marL="0" lvl="0" indent="0">
               <a:buNone/>
             </a:pPr>
             <a:r>
-              <a:rPr/>
               <a:t>总结</a:t>
             </a:r>
           </a:p>
@@ -3981,80 +4518,132 @@
         </p:nvSpPr>
         <p:spPr/>
         <p:txBody>
-          <a:bodyPr/>
+          <a:bodyPr>
+            <a:noAutofit/>
+          </a:bodyPr>
           <a:lstStyle/>
           <a:p>
-            <a:pPr lvl="0" indent="-342900" marL="342900">
+            <a:pPr marL="342900" lvl="0" indent="-342900">
               <a:buAutoNum type="arabicPeriod"/>
             </a:pPr>
             <a:r>
-              <a:rPr b="1"/>
-              <a:t>WiFi：</a:t>
-            </a:r>
-            <a:r>
-              <a:rPr/>
-              <a:t> 先找出等待放大，再适配 D80，最后用聚合与额度缓存降低每包固定成本。</a:t>
-            </a:r>
-          </a:p>
-          <a:p>
-            <a:pPr lvl="0" indent="-342900" marL="342900">
+              <a:rPr sz="1800" b="1" dirty="0" err="1"/>
+              <a:t>WiFi</a:t>
+            </a:r>
+            <a:r>
+              <a:rPr sz="1800" b="1" dirty="0"/>
+              <a:t>：</a:t>
+            </a:r>
+            <a:r>
+              <a:rPr sz="1800" dirty="0"/>
+              <a:t> </a:t>
+            </a:r>
+            <a:r>
+              <a:rPr sz="1800" dirty="0" err="1"/>
+              <a:t>先定位等待放大，再适配</a:t>
+            </a:r>
+            <a:r>
+              <a:rPr sz="1800" dirty="0"/>
+              <a:t> D80，最后用聚合与额度缓存降低每包固定成本。</a:t>
+            </a:r>
+          </a:p>
+          <a:p>
+            <a:pPr marL="342900" lvl="0" indent="-342900">
               <a:buAutoNum type="arabicPeriod"/>
             </a:pPr>
             <a:r>
-              <a:rPr b="1"/>
-              <a:t>结果：</a:t>
-            </a:r>
-            <a:r>
-              <a:rPr/>
-              <a:t> 新架构下，上行 </a:t>
-            </a:r>
-            <a:r>
-              <a:rPr b="1"/>
-              <a:t>7.30 → 40.0 Mbps</a:t>
-            </a:r>
-            <a:r>
-              <a:rPr/>
-              <a:t>，下行 </a:t>
-            </a:r>
-            <a:r>
-              <a:rPr b="1"/>
-              <a:t>20.3 → 35.2 Mbps</a:t>
-            </a:r>
-            <a:r>
-              <a:rPr/>
-              <a:t>；结果需结合会话波动解读。</a:t>
-            </a:r>
-          </a:p>
-          <a:p>
-            <a:pPr lvl="0" indent="-342900" marL="342900">
+              <a:rPr sz="1800" b="1" dirty="0" err="1"/>
+              <a:t>结果</a:t>
+            </a:r>
+            <a:r>
+              <a:rPr sz="1800" b="1" dirty="0"/>
+              <a:t>：</a:t>
+            </a:r>
+            <a:r>
+              <a:rPr sz="1800" dirty="0"/>
+              <a:t> </a:t>
+            </a:r>
+            <a:r>
+              <a:rPr sz="1800" dirty="0" err="1"/>
+              <a:t>新架构下上行</a:t>
+            </a:r>
+            <a:r>
+              <a:rPr sz="1800" dirty="0"/>
+              <a:t> 7.30 → 40.0 </a:t>
+            </a:r>
+            <a:r>
+              <a:rPr sz="1800" dirty="0" err="1"/>
+              <a:t>Mbps，下行</a:t>
+            </a:r>
+            <a:r>
+              <a:rPr sz="1800" dirty="0"/>
+              <a:t> 20.3 → 35.2 </a:t>
+            </a:r>
+            <a:r>
+              <a:rPr sz="1800" dirty="0" err="1"/>
+              <a:t>Mbps；结果需结合会话波动解读，实板验证覆盖</a:t>
+            </a:r>
+            <a:r>
+              <a:rPr sz="1800" dirty="0"/>
+              <a:t> D80、未覆盖 DC </a:t>
+            </a:r>
+            <a:r>
+              <a:rPr sz="1800" dirty="0" err="1"/>
+              <a:t>型号</a:t>
+            </a:r>
+            <a:r>
+              <a:rPr sz="1800" dirty="0"/>
+              <a:t>。</a:t>
+            </a:r>
+          </a:p>
+          <a:p>
+            <a:pPr marL="342900" lvl="0" indent="-342900">
               <a:buAutoNum type="arabicPeriod"/>
             </a:pPr>
             <a:r>
-              <a:rPr b="1"/>
-              <a:t>观测：</a:t>
-            </a:r>
-            <a:r>
-              <a:rPr/>
-              <a:t> 从接口累计，到队列快照，再到可由 eBPF 消费的状态事件，形成可复用的定位路径。</a:t>
-            </a:r>
-          </a:p>
-          <a:p>
-            <a:pPr lvl="0" indent="0" marL="0">
-              <a:buNone/>
-            </a:pPr>
-            <a:r>
-              <a:rPr b="1"/>
-              <a:t>下一步：</a:t>
-            </a:r>
-            <a:r>
-              <a:rPr/>
-              <a:t> 补多轮同口径板测；量化观测开启/关闭的吞吐与 CPU 成本。</a:t>
+              <a:rPr sz="1800" b="1" dirty="0" err="1"/>
+              <a:t>观测</a:t>
+            </a:r>
+            <a:r>
+              <a:rPr sz="1800" b="1" dirty="0"/>
+              <a:t>：</a:t>
+            </a:r>
+            <a:r>
+              <a:rPr sz="1800" dirty="0"/>
+              <a:t> </a:t>
+            </a:r>
+            <a:r>
+              <a:rPr sz="1800" dirty="0" err="1"/>
+              <a:t>从接口累计，到队列快照，再到可由</a:t>
+            </a:r>
+            <a:r>
+              <a:rPr sz="1800" dirty="0"/>
+              <a:t> </a:t>
+            </a:r>
+            <a:r>
+              <a:rPr sz="1800" dirty="0" err="1"/>
+              <a:t>eBPF</a:t>
+            </a:r>
+            <a:r>
+              <a:rPr sz="1800" dirty="0"/>
+              <a:t> </a:t>
+            </a:r>
+            <a:r>
+              <a:rPr sz="1800" dirty="0" err="1"/>
+              <a:t>消费的状态事件，形成可复用的定位路径</a:t>
+            </a:r>
+            <a:r>
+              <a:rPr sz="1800" dirty="0"/>
+              <a:t>。</a:t>
             </a:r>
           </a:p>
         </p:txBody>
       </p:sp>
     </p:spTree>
   </p:cSld>
+  <p:clrMapOvr>
+    <a:masterClrMapping/>
+  </p:clrMapOvr>
 </p:sld>
 </file>
 
@@ -4090,11 +4679,10 @@
           <a:bodyPr/>
           <a:lstStyle/>
           <a:p>
-            <a:pPr lvl="0" indent="0" marL="0">
+            <a:pPr marL="0" lvl="0" indent="0">
               <a:buNone/>
             </a:pPr>
             <a:r>
-              <a:rPr/>
               <a:t>工作主线</a:t>
             </a:r>
           </a:p>
@@ -4112,7 +4700,7 @@
         </p:nvGraphicFramePr>
         <p:xfrm>
           <a:off x="457200" y="1193800"/>
-          <a:ext cx="8229600" cy="3390900"/>
+          <a:ext cx="8229600" cy="1097280"/>
         </p:xfrm>
         <a:graphic>
           <a:graphicData uri="http://schemas.openxmlformats.org/drawingml/2006/table">
@@ -4121,9 +4709,27 @@
                 <a:tableStyleId>{5C22544A-7EE6-4342-B048-85BDC9FD1C3A}</a:tableStyleId>
               </a:tblPr>
               <a:tblGrid>
-                <a:gridCol w="2743200"/>
-                <a:gridCol w="2743200"/>
-                <a:gridCol w="2743200"/>
+                <a:gridCol w="2743200">
+                  <a:extLst>
+                    <a:ext uri="{9D8B030D-6E8A-4147-A177-3AD203B41FA5}">
+                      <a16:colId xmlns:a16="http://schemas.microsoft.com/office/drawing/2014/main" val="20000"/>
+                    </a:ext>
+                  </a:extLst>
+                </a:gridCol>
+                <a:gridCol w="2743200">
+                  <a:extLst>
+                    <a:ext uri="{9D8B030D-6E8A-4147-A177-3AD203B41FA5}">
+                      <a16:colId xmlns:a16="http://schemas.microsoft.com/office/drawing/2014/main" val="20001"/>
+                    </a:ext>
+                  </a:extLst>
+                </a:gridCol>
+                <a:gridCol w="2743200">
+                  <a:extLst>
+                    <a:ext uri="{9D8B030D-6E8A-4147-A177-3AD203B41FA5}">
+                      <a16:colId xmlns:a16="http://schemas.microsoft.com/office/drawing/2014/main" val="20002"/>
+                    </a:ext>
+                  </a:extLst>
+                </a:gridCol>
               </a:tblGrid>
               <a:tr h="0">
                 <a:tc>
@@ -4131,11 +4737,10 @@
                     <a:bodyPr/>
                     <a:lstStyle/>
                     <a:p>
-                      <a:pPr lvl="0" indent="0" marL="0">
+                      <a:pPr marL="0" lvl="0" indent="0">
                         <a:buNone/>
                       </a:pPr>
                       <a:r>
-                        <a:rPr/>
                         <a:t>方向</a:t>
                       </a:r>
                     </a:p>
@@ -4147,11 +4752,10 @@
                     <a:bodyPr/>
                     <a:lstStyle/>
                     <a:p>
-                      <a:pPr lvl="0" indent="0" marL="0">
+                      <a:pPr marL="0" lvl="0" indent="0">
                         <a:buNone/>
                       </a:pPr>
                       <a:r>
-                        <a:rPr/>
                         <a:t>要解决的问题</a:t>
                       </a:r>
                     </a:p>
@@ -4163,17 +4767,21 @@
                     <a:bodyPr/>
                     <a:lstStyle/>
                     <a:p>
-                      <a:pPr lvl="0" indent="0" marL="0">
+                      <a:pPr marL="0" lvl="0" indent="0">
                         <a:buNone/>
                       </a:pPr>
                       <a:r>
-                        <a:rPr/>
                         <a:t>形成的能力</a:t>
                       </a:r>
                     </a:p>
                   </a:txBody>
                   <a:tcPr/>
                 </a:tc>
+                <a:extLst>
+                  <a:ext uri="{0D108BD9-81ED-4DB2-BD59-A6C34878D82A}">
+                    <a16:rowId xmlns:a16="http://schemas.microsoft.com/office/drawing/2014/main" val="10000"/>
+                  </a:ext>
+                </a:extLst>
               </a:tr>
               <a:tr h="0">
                 <a:tc>
@@ -4181,46 +4789,51 @@
                     <a:bodyPr/>
                     <a:lstStyle/>
                     <a:p>
-                      <a:pPr lvl="0" indent="0" marL="0">
+                      <a:pPr marL="0" lvl="0" indent="0">
                         <a:buNone/>
                       </a:pPr>
                       <a:r>
-                        <a:rPr/>
                         <a:t>SG2002 WiFi</a:t>
                       </a:r>
                     </a:p>
                   </a:txBody>
+                  <a:tcPr/>
                 </a:tc>
                 <a:tc>
                   <a:txBody>
                     <a:bodyPr/>
                     <a:lstStyle/>
                     <a:p>
-                      <a:pPr lvl="0" indent="0" marL="0">
+                      <a:pPr marL="0" lvl="0" indent="0">
                         <a:buNone/>
                       </a:pPr>
                       <a:r>
-                        <a:rPr/>
                         <a:t>上行停顿、D80 适配、每包 SDIO 固定开销</a:t>
                       </a:r>
                     </a:p>
                   </a:txBody>
+                  <a:tcPr/>
                 </a:tc>
                 <a:tc>
                   <a:txBody>
                     <a:bodyPr/>
                     <a:lstStyle/>
                     <a:p>
-                      <a:pPr lvl="0" indent="0" marL="0">
+                      <a:pPr marL="0" lvl="0" indent="0">
                         <a:buNone/>
                       </a:pPr>
                       <a:r>
-                        <a:rPr/>
                         <a:t>稳定收发与多帧聚合</a:t>
                       </a:r>
                     </a:p>
                   </a:txBody>
+                  <a:tcPr/>
                 </a:tc>
+                <a:extLst>
+                  <a:ext uri="{0D108BD9-81ED-4DB2-BD59-A6C34878D82A}">
+                    <a16:rowId xmlns:a16="http://schemas.microsoft.com/office/drawing/2014/main" val="10001"/>
+                  </a:ext>
+                </a:extLst>
               </a:tr>
               <a:tr h="0">
                 <a:tc>
@@ -4228,46 +4841,51 @@
                     <a:bodyPr/>
                     <a:lstStyle/>
                     <a:p>
-                      <a:pPr lvl="0" indent="0" marL="0">
+                      <a:pPr marL="0" lvl="0" indent="0">
                         <a:buNone/>
                       </a:pPr>
                       <a:r>
-                        <a:rPr/>
                         <a:t>ax-net / eBPF</a:t>
                       </a:r>
                     </a:p>
                   </a:txBody>
+                  <a:tcPr/>
                 </a:tc>
                 <a:tc>
                   <a:txBody>
                     <a:bodyPr/>
                     <a:lstStyle/>
                     <a:p>
-                      <a:pPr lvl="0" indent="0" marL="0">
+                      <a:pPr marL="0" lvl="0" indent="0">
                         <a:buNone/>
                       </a:pPr>
                       <a:r>
-                        <a:rPr/>
                         <a:t>吞吐数字无法定位阻塞层次</a:t>
                       </a:r>
                     </a:p>
                   </a:txBody>
+                  <a:tcPr/>
                 </a:tc>
                 <a:tc>
                   <a:txBody>
                     <a:bodyPr/>
                     <a:lstStyle/>
                     <a:p>
-                      <a:pPr lvl="0" indent="0" marL="0">
+                      <a:pPr marL="0" lvl="0" indent="0">
                         <a:buNone/>
                       </a:pPr>
                       <a:r>
-                        <a:rPr/>
                         <a:t>接口计数、队列快照、静态事件</a:t>
                       </a:r>
                     </a:p>
                   </a:txBody>
+                  <a:tcPr/>
                 </a:tc>
+                <a:extLst>
+                  <a:ext uri="{0D108BD9-81ED-4DB2-BD59-A6C34878D82A}">
+                    <a16:rowId xmlns:a16="http://schemas.microsoft.com/office/drawing/2014/main" val="10002"/>
+                  </a:ext>
+                </a:extLst>
               </a:tr>
             </a:tbl>
           </a:graphicData>
@@ -4275,6 +4893,9 @@
       </p:graphicFrame>
     </p:spTree>
   </p:cSld>
+  <p:clrMapOvr>
+    <a:masterClrMapping/>
+  </p:clrMapOvr>
 </p:sld>
 </file>
 
@@ -4310,11 +4931,10 @@
           <a:bodyPr/>
           <a:lstStyle/>
           <a:p>
-            <a:pPr lvl="0" indent="0" marL="0">
+            <a:pPr marL="0" lvl="0" indent="0">
               <a:buNone/>
             </a:pPr>
             <a:r>
-              <a:rPr/>
               <a:t>WiFi：问题从哪里来</a:t>
             </a:r>
           </a:p>
@@ -4322,9 +4942,15 @@
       </p:sp>
       <p:pic>
         <p:nvPicPr>
-          <p:cNvPr descr="assets/wifi_wait.svg" id="0" name="Picture 1"/>
+          <p:cNvPr id="5" name="图片 4">
+            <a:extLst>
+              <a:ext uri="{FF2B5EF4-FFF2-40B4-BE49-F238E27FC236}">
+                <a16:creationId xmlns:a16="http://schemas.microsoft.com/office/drawing/2014/main" id="{ED6CFCEA-FEDD-1768-D821-57434238C864}"/>
+              </a:ext>
+            </a:extLst>
+          </p:cNvPr>
           <p:cNvPicPr>
-            <a:picLocks noGrp="1" noChangeAspect="1"/>
+            <a:picLocks noChangeAspect="1"/>
           </p:cNvPicPr>
           <p:nvPr/>
         </p:nvPicPr>
@@ -4334,24 +4960,21 @@
             <a:fillRect/>
           </a:stretch>
         </p:blipFill>
-        <p:spPr bwMode="auto">
+        <p:spPr>
           <a:xfrm>
-            <a:off x="508000" y="1193800"/>
-            <a:ext cx="8140700" cy="3390900"/>
+            <a:off x="1889760" y="1099151"/>
+            <a:ext cx="5726736" cy="3838370"/>
           </a:xfrm>
           <a:prstGeom prst="rect">
             <a:avLst/>
           </a:prstGeom>
-          <a:noFill/>
-          <a:ln w="9525">
-            <a:noFill/>
-            <a:headEnd/>
-            <a:tailEnd/>
-          </a:ln>
         </p:spPr>
       </p:pic>
     </p:spTree>
   </p:cSld>
+  <p:clrMapOvr>
+    <a:masterClrMapping/>
+  </p:clrMapOvr>
 </p:sld>
 </file>
 
@@ -4387,11 +5010,10 @@
           <a:bodyPr/>
           <a:lstStyle/>
           <a:p>
-            <a:pPr lvl="0" indent="0" marL="0">
+            <a:pPr marL="0" lvl="0" indent="0">
               <a:buNone/>
             </a:pPr>
             <a:r>
-              <a:rPr/>
               <a:t>WiFi：修复完成等待</a:t>
             </a:r>
           </a:p>
@@ -4409,7 +5031,7 @@
         </p:nvGraphicFramePr>
         <p:xfrm>
           <a:off x="457200" y="1193800"/>
-          <a:ext cx="8229600" cy="3390900"/>
+          <a:ext cx="8229600" cy="2514600"/>
         </p:xfrm>
         <a:graphic>
           <a:graphicData uri="http://schemas.openxmlformats.org/drawingml/2006/table">
@@ -4418,8 +5040,20 @@
                 <a:tableStyleId>{5C22544A-7EE6-4342-B048-85BDC9FD1C3A}</a:tableStyleId>
               </a:tblPr>
               <a:tblGrid>
-                <a:gridCol w="4114800"/>
-                <a:gridCol w="4114800"/>
+                <a:gridCol w="4114800">
+                  <a:extLst>
+                    <a:ext uri="{9D8B030D-6E8A-4147-A177-3AD203B41FA5}">
+                      <a16:colId xmlns:a16="http://schemas.microsoft.com/office/drawing/2014/main" val="20000"/>
+                    </a:ext>
+                  </a:extLst>
+                </a:gridCol>
+                <a:gridCol w="4114800">
+                  <a:extLst>
+                    <a:ext uri="{9D8B030D-6E8A-4147-A177-3AD203B41FA5}">
+                      <a16:colId xmlns:a16="http://schemas.microsoft.com/office/drawing/2014/main" val="20001"/>
+                    </a:ext>
+                  </a:extLst>
+                </a:gridCol>
               </a:tblGrid>
               <a:tr h="0">
                 <a:tc>
@@ -4427,11 +5061,10 @@
                     <a:bodyPr/>
                     <a:lstStyle/>
                     <a:p>
-                      <a:pPr lvl="0" indent="0" marL="0">
+                      <a:pPr marL="0" lvl="0" indent="0">
                         <a:buNone/>
                       </a:pPr>
                       <a:r>
-                        <a:rPr/>
                         <a:t>关键边界</a:t>
                       </a:r>
                     </a:p>
@@ -4443,17 +5076,21 @@
                     <a:bodyPr/>
                     <a:lstStyle/>
                     <a:p>
-                      <a:pPr lvl="0" indent="0" marL="0">
+                      <a:pPr marL="0" lvl="0" indent="0">
                         <a:buNone/>
                       </a:pPr>
                       <a:r>
-                        <a:rPr/>
                         <a:t>处理方式</a:t>
                       </a:r>
                     </a:p>
                   </a:txBody>
                   <a:tcPr/>
                 </a:tc>
+                <a:extLst>
+                  <a:ext uri="{0D108BD9-81ED-4DB2-BD59-A6C34878D82A}">
+                    <a16:rowId xmlns:a16="http://schemas.microsoft.com/office/drawing/2014/main" val="10000"/>
+                  </a:ext>
+                </a:extLst>
               </a:tr>
               <a:tr h="0">
                 <a:tc>
@@ -4461,26 +5098,25 @@
                     <a:bodyPr/>
                     <a:lstStyle/>
                     <a:p>
-                      <a:pPr lvl="0" indent="0" marL="0">
+                      <a:pPr marL="0" lvl="0" indent="0">
                         <a:buNone/>
                       </a:pPr>
                       <a:r>
-                        <a:rPr/>
                         <a:t>完成通知</a:t>
                       </a:r>
                     </a:p>
                   </a:txBody>
+                  <a:tcPr/>
                 </a:tc>
                 <a:tc>
                   <a:txBody>
                     <a:bodyPr/>
                     <a:lstStyle/>
                     <a:p>
-                      <a:pPr lvl="0" indent="0" marL="0">
+                      <a:pPr marL="0" lvl="0" indent="0">
                         <a:buNone/>
                       </a:pPr>
                       <a:r>
-                        <a:rPr/>
                         <a:t>使能 </a:t>
                       </a:r>
                       <a:r>
@@ -4490,12 +5126,26 @@
                         <a:t>XFER_COMPLETE</a:t>
                       </a:r>
                       <a:r>
-                        <a:rPr/>
-                        <a:t>；中断只屏蔽信号并唤醒，任务消费粘滞状态位</a:t>
+                        <a:t>（</a:t>
+                      </a:r>
+                      <a:r>
+                        <a:rPr>
+                          <a:latin typeface="Courier"/>
+                        </a:rPr>
+                        <a:t>INT_STATUS_NORM</a:t>
+                      </a:r>
+                      <a:r>
+                        <a:t> 0x30 bit1）；中断只屏蔽信号并唤醒，粘滞状态位由任务侧消费</a:t>
                       </a:r>
                     </a:p>
                   </a:txBody>
+                  <a:tcPr/>
                 </a:tc>
+                <a:extLst>
+                  <a:ext uri="{0D108BD9-81ED-4DB2-BD59-A6C34878D82A}">
+                    <a16:rowId xmlns:a16="http://schemas.microsoft.com/office/drawing/2014/main" val="10001"/>
+                  </a:ext>
+                </a:extLst>
               </a:tr>
               <a:tr h="0">
                 <a:tc>
@@ -4503,31 +5153,36 @@
                     <a:bodyPr/>
                     <a:lstStyle/>
                     <a:p>
-                      <a:pPr lvl="0" indent="0" marL="0">
+                      <a:pPr marL="0" lvl="0" indent="0">
                         <a:buNone/>
                       </a:pPr>
                       <a:r>
-                        <a:rPr/>
                         <a:t>丢唤醒</a:t>
                       </a:r>
                     </a:p>
                   </a:txBody>
+                  <a:tcPr/>
                 </a:tc>
                 <a:tc>
                   <a:txBody>
                     <a:bodyPr/>
                     <a:lstStyle/>
                     <a:p>
-                      <a:pPr lvl="0" indent="0" marL="0">
+                      <a:pPr marL="0" lvl="0" indent="0">
                         <a:buNone/>
                       </a:pPr>
                       <a:r>
-                        <a:rPr/>
-                        <a:t>状态复检与等待入队放入同一关中断临界区</a:t>
+                        <a:t>条件复检与入队收进同一关中断临界区，关闭「中断先到、任务后入队」的窗口</a:t>
                       </a:r>
                     </a:p>
                   </a:txBody>
+                  <a:tcPr/>
                 </a:tc>
+                <a:extLst>
+                  <a:ext uri="{0D108BD9-81ED-4DB2-BD59-A6C34878D82A}">
+                    <a16:rowId xmlns:a16="http://schemas.microsoft.com/office/drawing/2014/main" val="10002"/>
+                  </a:ext>
+                </a:extLst>
               </a:tr>
               <a:tr h="0">
                 <a:tc>
@@ -4535,31 +5190,45 @@
                     <a:bodyPr/>
                     <a:lstStyle/>
                     <a:p>
-                      <a:pPr lvl="0" indent="0" marL="0">
+                      <a:pPr marL="0" lvl="0" indent="0">
                         <a:buNone/>
                       </a:pPr>
                       <a:r>
-                        <a:rPr/>
                         <a:t>状态清理</a:t>
                       </a:r>
                     </a:p>
                   </a:txBody>
+                  <a:tcPr/>
                 </a:tc>
                 <a:tc>
                   <a:txBody>
                     <a:bodyPr/>
                     <a:lstStyle/>
                     <a:p>
-                      <a:pPr lvl="0" indent="0" marL="0">
+                      <a:pPr marL="0" lvl="0" indent="0">
                         <a:buNone/>
                       </a:pPr>
                       <a:r>
-                        <a:rPr/>
-                        <a:t>选择性 W1C，避免并发命令抹掉另一传输的完成位</a:t>
+                        <a:t>选择性 W1C，与 </a:t>
+                      </a:r>
+                      <a:r>
+                        <a:rPr>
+                          <a:latin typeface="Courier"/>
+                        </a:rPr>
+                        <a:t>!(NORM_INT_XFER_COMPLETE)</a:t>
+                      </a:r>
+                      <a:r>
+                        <a:t> 相与，只清其余位，不抹掉并发传输的完成位</a:t>
                       </a:r>
                     </a:p>
                   </a:txBody>
+                  <a:tcPr/>
                 </a:tc>
+                <a:extLst>
+                  <a:ext uri="{0D108BD9-81ED-4DB2-BD59-A6C34878D82A}">
+                    <a16:rowId xmlns:a16="http://schemas.microsoft.com/office/drawing/2014/main" val="10003"/>
+                  </a:ext>
+                </a:extLst>
               </a:tr>
               <a:tr h="0">
                 <a:tc>
@@ -4567,31 +5236,45 @@
                     <a:bodyPr/>
                     <a:lstStyle/>
                     <a:p>
-                      <a:pPr lvl="0" indent="0" marL="0">
+                      <a:pPr marL="0" lvl="0" indent="0">
                         <a:buNone/>
                       </a:pPr>
                       <a:r>
-                        <a:rPr/>
                         <a:t>MMIO 顺序</a:t>
                       </a:r>
                     </a:p>
                   </a:txBody>
+                  <a:tcPr/>
                 </a:tc>
                 <a:tc>
                   <a:txBody>
                     <a:bodyPr/>
                     <a:lstStyle/>
                     <a:p>
-                      <a:pPr lvl="0" indent="0" marL="0">
+                      <a:pPr marL="0" lvl="0" indent="0">
                         <a:buNone/>
                       </a:pPr>
                       <a:r>
-                        <a:rPr/>
-                        <a:t>轮询前排空写缓冲，避免漏读完成状态</a:t>
+                        <a:t>自旋入口加一次 </a:t>
+                      </a:r>
+                      <a:r>
+                        <a:rPr>
+                          <a:latin typeface="Courier"/>
+                        </a:rPr>
+                        <a:t>fence(SeqCst)</a:t>
+                      </a:r>
+                      <a:r>
+                        <a:t>，避免写缓冲与完成状态读取争用总线</a:t>
                       </a:r>
                     </a:p>
                   </a:txBody>
+                  <a:tcPr/>
                 </a:tc>
+                <a:extLst>
+                  <a:ext uri="{0D108BD9-81ED-4DB2-BD59-A6C34878D82A}">
+                    <a16:rowId xmlns:a16="http://schemas.microsoft.com/office/drawing/2014/main" val="10004"/>
+                  </a:ext>
+                </a:extLst>
               </a:tr>
             </a:tbl>
           </a:graphicData>
@@ -4599,6 +5282,9 @@
       </p:graphicFrame>
     </p:spTree>
   </p:cSld>
+  <p:clrMapOvr>
+    <a:masterClrMapping/>
+  </p:clrMapOvr>
 </p:sld>
 </file>
 
@@ -4634,11 +5320,10 @@
           <a:bodyPr/>
           <a:lstStyle/>
           <a:p>
-            <a:pPr lvl="0" indent="0" marL="0">
+            <a:pPr marL="0" lvl="0" indent="0">
               <a:buNone/>
             </a:pPr>
             <a:r>
-              <a:rPr/>
               <a:t>WiFi：重构后的驱动结构</a:t>
             </a:r>
           </a:p>
@@ -4646,7 +5331,7 @@
       </p:sp>
       <p:pic>
         <p:nvPicPr>
-          <p:cNvPr descr="assets/wifi_stack.svg" id="0" name="Picture 1"/>
+          <p:cNvPr id="3" name="Picture 1" descr="figures/f2_layers.png"/>
           <p:cNvPicPr>
             <a:picLocks noGrp="1" noChangeAspect="1"/>
           </p:cNvPicPr>
@@ -4660,8 +5345,8 @@
         </p:blipFill>
         <p:spPr bwMode="auto">
           <a:xfrm>
-            <a:off x="508000" y="1193800"/>
-            <a:ext cx="8140700" cy="3390900"/>
+            <a:off x="457200" y="2197100"/>
+            <a:ext cx="8229600" cy="1384300"/>
           </a:xfrm>
           <a:prstGeom prst="rect">
             <a:avLst/>
@@ -4676,6 +5361,9 @@
       </p:pic>
     </p:spTree>
   </p:cSld>
+  <p:clrMapOvr>
+    <a:masterClrMapping/>
+  </p:clrMapOvr>
 </p:sld>
 </file>
 
@@ -4711,11 +5399,10 @@
           <a:bodyPr/>
           <a:lstStyle/>
           <a:p>
-            <a:pPr lvl="0" indent="0" marL="0">
+            <a:pPr marL="0" lvl="0" indent="0">
               <a:buNone/>
             </a:pPr>
             <a:r>
-              <a:rPr/>
               <a:t>D80 适配：三类故障</a:t>
             </a:r>
           </a:p>
@@ -4733,7 +5420,7 @@
         </p:nvGraphicFramePr>
         <p:xfrm>
           <a:off x="457200" y="1193800"/>
-          <a:ext cx="8229600" cy="3390900"/>
+          <a:ext cx="8229600" cy="2217420"/>
         </p:xfrm>
         <a:graphic>
           <a:graphicData uri="http://schemas.openxmlformats.org/drawingml/2006/table">
@@ -4742,9 +5429,27 @@
                 <a:tableStyleId>{5C22544A-7EE6-4342-B048-85BDC9FD1C3A}</a:tableStyleId>
               </a:tblPr>
               <a:tblGrid>
-                <a:gridCol w="2743200"/>
-                <a:gridCol w="2743200"/>
-                <a:gridCol w="2743200"/>
+                <a:gridCol w="2743200">
+                  <a:extLst>
+                    <a:ext uri="{9D8B030D-6E8A-4147-A177-3AD203B41FA5}">
+                      <a16:colId xmlns:a16="http://schemas.microsoft.com/office/drawing/2014/main" val="20000"/>
+                    </a:ext>
+                  </a:extLst>
+                </a:gridCol>
+                <a:gridCol w="2743200">
+                  <a:extLst>
+                    <a:ext uri="{9D8B030D-6E8A-4147-A177-3AD203B41FA5}">
+                      <a16:colId xmlns:a16="http://schemas.microsoft.com/office/drawing/2014/main" val="20001"/>
+                    </a:ext>
+                  </a:extLst>
+                </a:gridCol>
+                <a:gridCol w="2743200">
+                  <a:extLst>
+                    <a:ext uri="{9D8B030D-6E8A-4147-A177-3AD203B41FA5}">
+                      <a16:colId xmlns:a16="http://schemas.microsoft.com/office/drawing/2014/main" val="20002"/>
+                    </a:ext>
+                  </a:extLst>
+                </a:gridCol>
               </a:tblGrid>
               <a:tr h="0">
                 <a:tc>
@@ -4752,11 +5457,10 @@
                     <a:bodyPr/>
                     <a:lstStyle/>
                     <a:p>
-                      <a:pPr lvl="0" indent="0" marL="0">
+                      <a:pPr marL="0" lvl="0" indent="0">
                         <a:buNone/>
                       </a:pPr>
                       <a:r>
-                        <a:rPr/>
                         <a:t>现象</a:t>
                       </a:r>
                     </a:p>
@@ -4768,11 +5472,10 @@
                     <a:bodyPr/>
                     <a:lstStyle/>
                     <a:p>
-                      <a:pPr lvl="0" indent="0" marL="0">
+                      <a:pPr marL="0" lvl="0" indent="0">
                         <a:buNone/>
                       </a:pPr>
                       <a:r>
-                        <a:rPr/>
                         <a:t>根因</a:t>
                       </a:r>
                     </a:p>
@@ -4784,17 +5487,21 @@
                     <a:bodyPr/>
                     <a:lstStyle/>
                     <a:p>
-                      <a:pPr lvl="0" indent="0" marL="0">
+                      <a:pPr marL="0" lvl="0" indent="0">
                         <a:buNone/>
                       </a:pPr>
                       <a:r>
-                        <a:rPr/>
                         <a:t>修复</a:t>
                       </a:r>
                     </a:p>
                   </a:txBody>
                   <a:tcPr/>
                 </a:tc>
+                <a:extLst>
+                  <a:ext uri="{0D108BD9-81ED-4DB2-BD59-A6C34878D82A}">
+                    <a16:rowId xmlns:a16="http://schemas.microsoft.com/office/drawing/2014/main" val="10000"/>
+                  </a:ext>
+                </a:extLst>
               </a:tr>
               <a:tr h="0">
                 <a:tc>
@@ -4802,46 +5509,51 @@
                     <a:bodyPr/>
                     <a:lstStyle/>
                     <a:p>
-                      <a:pPr lvl="0" indent="0" marL="0">
+                      <a:pPr marL="0" lvl="0" indent="0">
                         <a:buNone/>
                       </a:pPr>
                       <a:r>
-                        <a:rPr/>
                         <a:t>启动卡在固件回复</a:t>
                       </a:r>
                     </a:p>
                   </a:txBody>
+                  <a:tcPr/>
                 </a:tc>
                 <a:tc>
                   <a:txBody>
                     <a:bodyPr/>
                     <a:lstStyle/>
                     <a:p>
-                      <a:pPr lvl="0" indent="0" marL="0">
+                      <a:pPr marL="0" lvl="0" indent="0">
                         <a:buNone/>
                       </a:pPr>
                       <a:r>
-                        <a:rPr/>
-                        <a:t>刚唤醒时寄存器读回旧值；设备中断使能太晚</a:t>
+                        <a:t>浅睡时寄存器即时回读是旧值；设备中断使能太晚，ROM 邮箱阶段无卡中断</a:t>
                       </a:r>
                     </a:p>
                   </a:txBody>
+                  <a:tcPr/>
                 </a:tc>
                 <a:tc>
                   <a:txBody>
                     <a:bodyPr/>
                     <a:lstStyle/>
                     <a:p>
-                      <a:pPr lvl="0" indent="0" marL="0">
+                      <a:pPr marL="0" lvl="0" indent="0">
                         <a:buNone/>
                       </a:pPr>
                       <a:r>
-                        <a:rPr/>
-                        <a:t>调整写后检查；ROM 邮箱通信前启用中断</a:t>
+                        <a:t>写后改为形状校验；V3 序列新增 index 3，把中断使能提前到 ROM 邮箱阶段之前</a:t>
                       </a:r>
                     </a:p>
                   </a:txBody>
+                  <a:tcPr/>
                 </a:tc>
+                <a:extLst>
+                  <a:ext uri="{0D108BD9-81ED-4DB2-BD59-A6C34878D82A}">
+                    <a16:rowId xmlns:a16="http://schemas.microsoft.com/office/drawing/2014/main" val="10001"/>
+                  </a:ext>
+                </a:extLst>
               </a:tr>
               <a:tr h="0">
                 <a:tc>
@@ -4849,46 +5561,51 @@
                     <a:bodyPr/>
                     <a:lstStyle/>
                     <a:p>
-                      <a:pPr lvl="0" indent="0" marL="0">
+                      <a:pPr marL="0" lvl="0" indent="0">
                         <a:buNone/>
                       </a:pPr>
                       <a:r>
-                        <a:rPr/>
                         <a:t>AP 命令成功却搜不到热点</a:t>
                       </a:r>
                     </a:p>
                   </a:txBody>
+                  <a:tcPr/>
                 </a:tc>
                 <a:tc>
                   <a:txBody>
                     <a:bodyPr/>
                     <a:lstStyle/>
                     <a:p>
-                      <a:pPr lvl="0" indent="0" marL="0">
+                      <a:pPr marL="0" lvl="0" indent="0">
                         <a:buNone/>
                       </a:pPr>
                       <a:r>
-                        <a:rPr/>
-                        <a:t>AP 接口编号硬编码为 0</a:t>
+                        <a:t>AP 接口编号硬编码为 0，固件分配的编号是 1</a:t>
                       </a:r>
                     </a:p>
                   </a:txBody>
+                  <a:tcPr/>
                 </a:tc>
                 <a:tc>
                   <a:txBody>
                     <a:bodyPr/>
                     <a:lstStyle/>
                     <a:p>
-                      <a:pPr lvl="0" indent="0" marL="0">
+                      <a:pPr marL="0" lvl="0" indent="0">
                         <a:buNone/>
                       </a:pPr>
                       <a:r>
-                        <a:rPr/>
-                        <a:t>采用固件分配的 vif 编号，校验确认状态</a:t>
+                        <a:t>回填固件分配的 vif 编号，并校验确认长度、状态码与编号</a:t>
                       </a:r>
                     </a:p>
                   </a:txBody>
+                  <a:tcPr/>
                 </a:tc>
+                <a:extLst>
+                  <a:ext uri="{0D108BD9-81ED-4DB2-BD59-A6C34878D82A}">
+                    <a16:rowId xmlns:a16="http://schemas.microsoft.com/office/drawing/2014/main" val="10002"/>
+                  </a:ext>
+                </a:extLst>
               </a:tr>
               <a:tr h="0">
                 <a:tc>
@@ -4896,46 +5613,75 @@
                     <a:bodyPr/>
                     <a:lstStyle/>
                     <a:p>
-                      <a:pPr lvl="0" indent="0" marL="0">
+                      <a:pPr marL="0" lvl="0" indent="0">
                         <a:buNone/>
                       </a:pPr>
                       <a:r>
-                        <a:rPr/>
                         <a:t>负载数秒后收发停摆</a:t>
                       </a:r>
                     </a:p>
                   </a:txBody>
+                  <a:tcPr/>
                 </a:tc>
                 <a:tc>
                   <a:txBody>
                     <a:bodyPr/>
                     <a:lstStyle/>
                     <a:p>
-                      <a:pPr lvl="0" indent="0" marL="0">
+                      <a:pPr marL="0" lvl="0" indent="0">
                         <a:buNone/>
                       </a:pPr>
                       <a:r>
-                        <a:rPr/>
-                        <a:t>D80 额度 128 被七位掩码读成 0；重试时中断未重挂</a:t>
+                        <a:t>D80 额度 128（0x80）被七位掩码读成 0；重试路径不置 </a:t>
+                      </a:r>
+                      <a:r>
+                        <a:rPr>
+                          <a:latin typeface="Courier"/>
+                        </a:rPr>
+                        <a:t>Armed</a:t>
+                      </a:r>
+                      <a:r>
+                        <a:t>，中断永不重挂</a:t>
                       </a:r>
                     </a:p>
                   </a:txBody>
+                  <a:tcPr/>
                 </a:tc>
                 <a:tc>
                   <a:txBody>
                     <a:bodyPr/>
                     <a:lstStyle/>
                     <a:p>
-                      <a:pPr lvl="0" indent="0" marL="0">
+                      <a:pPr marL="0" lvl="0" indent="0">
                         <a:buNone/>
                       </a:pPr>
                       <a:r>
-                        <a:rPr/>
-                        <a:t>按 V3 解码额度与长度；重试允许中断重新使能</a:t>
+                        <a:t>按 V3 读完整 8 位；重试路径返回 </a:t>
+                      </a:r>
+                      <a:r>
+                        <a:rPr>
+                          <a:latin typeface="Courier"/>
+                        </a:rPr>
+                        <a:t>WaitForInterruptUntil</a:t>
+                      </a:r>
+                      <a:r>
+                        <a:t> 并置 </a:t>
+                      </a:r>
+                      <a:r>
+                        <a:rPr>
+                          <a:latin typeface="Courier"/>
+                        </a:rPr>
+                        <a:t>Armed</a:t>
                       </a:r>
                     </a:p>
                   </a:txBody>
+                  <a:tcPr/>
                 </a:tc>
+                <a:extLst>
+                  <a:ext uri="{0D108BD9-81ED-4DB2-BD59-A6C34878D82A}">
+                    <a16:rowId xmlns:a16="http://schemas.microsoft.com/office/drawing/2014/main" val="10003"/>
+                  </a:ext>
+                </a:extLst>
               </a:tr>
             </a:tbl>
           </a:graphicData>
@@ -4943,6 +5689,9 @@
       </p:graphicFrame>
     </p:spTree>
   </p:cSld>
+  <p:clrMapOvr>
+    <a:masterClrMapping/>
+  </p:clrMapOvr>
 </p:sld>
 </file>
 
@@ -4978,19 +5727,18 @@
           <a:bodyPr/>
           <a:lstStyle/>
           <a:p>
-            <a:pPr lvl="0" indent="0" marL="0">
+            <a:pPr marL="0" lvl="0" indent="0">
               <a:buNone/>
             </a:pPr>
             <a:r>
-              <a:rPr/>
-              <a:t>WiFi：发送瓶颈在“每包固定成本”</a:t>
+              <a:t>WiFi：发送瓶颈在「每包固定成本」</a:t>
             </a:r>
           </a:p>
         </p:txBody>
       </p:sp>
       <p:pic>
         <p:nvPicPr>
-          <p:cNvPr descr="assets/tx_aggregation.svg" id="0" name="Picture 1"/>
+          <p:cNvPr id="3" name="Picture 1" descr="figures/f3_txpath.png"/>
           <p:cNvPicPr>
             <a:picLocks noGrp="1" noChangeAspect="1"/>
           </p:cNvPicPr>
@@ -5004,8 +5752,8 @@
         </p:blipFill>
         <p:spPr bwMode="auto">
           <a:xfrm>
-            <a:off x="508000" y="1193800"/>
-            <a:ext cx="8140700" cy="3390900"/>
+            <a:off x="457200" y="1206500"/>
+            <a:ext cx="8229600" cy="3352800"/>
           </a:xfrm>
           <a:prstGeom prst="rect">
             <a:avLst/>
@@ -5020,6 +5768,9 @@
       </p:pic>
     </p:spTree>
   </p:cSld>
+  <p:clrMapOvr>
+    <a:masterClrMapping/>
+  </p:clrMapOvr>
 </p:sld>
 </file>
 
@@ -5055,11 +5806,10 @@
           <a:bodyPr/>
           <a:lstStyle/>
           <a:p>
-            <a:pPr lvl="0" indent="0" marL="0">
+            <a:pPr marL="0" lvl="0" indent="0">
               <a:buNone/>
             </a:pPr>
             <a:r>
-              <a:rPr/>
               <a:t>WiFi：聚合、额度缓存与有界续接</a:t>
             </a:r>
           </a:p>
@@ -5077,73 +5827,186 @@
         </p:nvSpPr>
         <p:spPr/>
         <p:txBody>
-          <a:bodyPr/>
+          <a:bodyPr>
+            <a:noAutofit/>
+          </a:bodyPr>
           <a:lstStyle/>
           <a:p>
-            <a:pPr lvl="0" indent="-342900" marL="342900">
-              <a:buAutoNum type="arabicPeriod"/>
+            <a:pPr lvl="0"/>
+            <a:r>
+              <a:rPr sz="1800" b="1" dirty="0" err="1"/>
+              <a:t>多帧一笔写</a:t>
+            </a:r>
+            <a:r>
+              <a:rPr sz="1800" b="1" dirty="0"/>
+              <a:t>：</a:t>
+            </a:r>
+            <a:r>
+              <a:rPr sz="1800" dirty="0"/>
+              <a:t> </a:t>
+            </a:r>
+            <a:r>
+              <a:rPr sz="1800" dirty="0" err="1"/>
+              <a:t>帧内按</a:t>
+            </a:r>
+            <a:r>
+              <a:rPr sz="1800" dirty="0"/>
+              <a:t> 4 </a:t>
+            </a:r>
+            <a:r>
+              <a:rPr sz="1800" dirty="0" err="1"/>
+              <a:t>字节对齐，整笔末尾补到</a:t>
+            </a:r>
+            <a:r>
+              <a:rPr sz="1800" dirty="0"/>
+              <a:t> 512 </a:t>
+            </a:r>
+            <a:r>
+              <a:rPr sz="1800" dirty="0" err="1"/>
+              <a:t>字节块边界；板级上限</a:t>
+            </a:r>
+            <a:r>
+              <a:rPr sz="1800" dirty="0"/>
+              <a:t> 32 帧、49152 </a:t>
+            </a:r>
+            <a:r>
+              <a:rPr sz="1800" dirty="0" err="1"/>
+              <a:t>字节，核心默认</a:t>
+            </a:r>
+            <a:r>
+              <a:rPr sz="1800" dirty="0"/>
+              <a:t> 4 帧、6144 </a:t>
+            </a:r>
+            <a:r>
+              <a:rPr sz="1800" dirty="0" err="1"/>
+              <a:t>字节</a:t>
+            </a:r>
+            <a:r>
+              <a:rPr sz="1800" dirty="0"/>
+              <a:t>。</a:t>
+            </a:r>
+          </a:p>
+          <a:p>
+            <a:pPr lvl="0"/>
+            <a:r>
+              <a:rPr sz="1800" b="1" dirty="0" err="1"/>
+              <a:t>额度缓存</a:t>
+            </a:r>
+            <a:r>
+              <a:rPr sz="1800" b="1" dirty="0"/>
+              <a:t>：</a:t>
+            </a:r>
+            <a:r>
+              <a:rPr sz="1800" dirty="0"/>
+              <a:t> D80 </a:t>
+            </a:r>
+            <a:r>
+              <a:rPr sz="1800" dirty="0" err="1"/>
+              <a:t>读完整</a:t>
+            </a:r>
+            <a:r>
+              <a:rPr sz="1800" dirty="0"/>
+              <a:t> 8 </a:t>
+            </a:r>
+            <a:r>
+              <a:rPr sz="1800" dirty="0" err="1"/>
+              <a:t>位，每发一包扣一个额度，保留</a:t>
+            </a:r>
+            <a:r>
+              <a:rPr sz="1800" dirty="0"/>
+              <a:t> 2 </a:t>
+            </a:r>
+            <a:r>
+              <a:rPr sz="1800" dirty="0" err="1"/>
+              <a:t>个给命令；命令流量与取消使缓存失效，读数不高于保留量时不缓存而是退避重读</a:t>
+            </a:r>
+            <a:r>
+              <a:rPr sz="1800" dirty="0"/>
+              <a:t>。</a:t>
+            </a:r>
+          </a:p>
+          <a:p>
+            <a:pPr lvl="0"/>
+            <a:r>
+              <a:rPr sz="1800" b="1" dirty="0" err="1"/>
+              <a:t>薄池有界等待</a:t>
+            </a:r>
+            <a:r>
+              <a:rPr sz="1800" b="1" dirty="0"/>
+              <a:t>：</a:t>
+            </a:r>
+            <a:r>
+              <a:rPr sz="1800" dirty="0"/>
+              <a:t> </a:t>
+            </a:r>
+            <a:r>
+              <a:rPr sz="1800" dirty="0" err="1"/>
+              <a:t>每次</a:t>
+            </a:r>
+            <a:r>
+              <a:rPr sz="1800" dirty="0"/>
+              <a:t> 300 µ</a:t>
+            </a:r>
+            <a:r>
+              <a:rPr sz="1800" dirty="0" err="1"/>
+              <a:t>s、最多</a:t>
+            </a:r>
+            <a:r>
+              <a:rPr sz="1800" dirty="0"/>
+              <a:t> 8 </a:t>
+            </a:r>
+            <a:r>
+              <a:rPr sz="1800" dirty="0" err="1"/>
+              <a:t>次；超过预算即按现有额度发出，不为凑大批次无限等待</a:t>
+            </a:r>
+            <a:r>
+              <a:rPr sz="1800" dirty="0"/>
+              <a:t>。</a:t>
+            </a:r>
+          </a:p>
+          <a:p>
+            <a:pPr lvl="0"/>
+            <a:r>
+              <a:rPr sz="1800" b="1" dirty="0" err="1"/>
+              <a:t>完成后续接</a:t>
+            </a:r>
+            <a:r>
+              <a:rPr sz="1800" b="1" dirty="0"/>
+              <a:t>：</a:t>
+            </a:r>
+            <a:r>
+              <a:rPr sz="1800" dirty="0"/>
+              <a:t> </a:t>
+            </a:r>
+            <a:r>
+              <a:rPr sz="1800" dirty="0" err="1"/>
+              <a:t>队列有帧且额度允许就准备下一笔，但每轮最多续接一次，把执行机会让给接收扫描</a:t>
+            </a:r>
+            <a:r>
+              <a:rPr sz="1800" dirty="0"/>
+              <a:t>。</a:t>
+            </a:r>
+          </a:p>
+          <a:p>
+            <a:pPr marL="0" lvl="0" indent="0">
+              <a:buNone/>
             </a:pPr>
             <a:r>
-              <a:rPr b="1"/>
-              <a:t>多帧一笔写：</a:t>
-            </a:r>
-            <a:r>
-              <a:rPr/>
-              <a:t> 帧内按 4 字节对齐，整笔末尾再补到 512 字节块边界；板级上限为 32 帧、49,152 字节。</a:t>
-            </a:r>
-          </a:p>
-          <a:p>
-            <a:pPr lvl="0" indent="-342900" marL="342900">
-              <a:buAutoNum type="arabicPeriod"/>
-            </a:pPr>
-            <a:r>
-              <a:rPr b="1"/>
-              <a:t>额度缓存：</a:t>
-            </a:r>
-            <a:r>
-              <a:rPr/>
-              <a:t> D80 读完整 8 位，每发一包扣一个额度，给命令保留两个；命令流量和取消使缓存失效。</a:t>
-            </a:r>
-          </a:p>
-          <a:p>
-            <a:pPr lvl="0" indent="-342900" marL="342900">
-              <a:buAutoNum type="arabicPeriod"/>
-            </a:pPr>
-            <a:r>
-              <a:rPr b="1"/>
-              <a:t>薄池有界等待：</a:t>
-            </a:r>
-            <a:r>
-              <a:rPr/>
-              <a:t> 每次 300 µs、最多 8 次；不足时按现有额度发出，不无限等批次。</a:t>
-            </a:r>
-          </a:p>
-          <a:p>
-            <a:pPr lvl="0" indent="-342900" marL="342900">
-              <a:buAutoNum type="arabicPeriod"/>
-            </a:pPr>
-            <a:r>
-              <a:rPr b="1"/>
-              <a:t>完成后续接：</a:t>
-            </a:r>
-            <a:r>
-              <a:rPr/>
-              <a:t> 队列有帧且额度允许就准备下一笔，但每轮最多续接一次，给接收扫描留机会。</a:t>
-            </a:r>
-          </a:p>
-          <a:p>
-            <a:pPr lvl="0" indent="0" marL="0">
-              <a:buNone/>
-            </a:pPr>
-            <a:r>
-              <a:rPr/>
-              <a:t>边界处理保证取消、停机、事件队列满时，发送缓冲只归还一次。</a:t>
+              <a:rPr sz="1800" dirty="0" err="1"/>
+              <a:t>边界处理保证取消、停机、事件队列满时，发送缓冲只归还一次</a:t>
+            </a:r>
+            <a:r>
+              <a:rPr sz="1800" dirty="0"/>
+              <a:t>。</a:t>
             </a:r>
           </a:p>
         </p:txBody>
       </p:sp>
     </p:spTree>
   </p:cSld>
+  <p:clrMapOvr>
+    <a:masterClrMapping/>
+  </p:clrMapOvr>
 </p:sld>
 </file>
 
@@ -5179,11 +6042,10 @@
           <a:bodyPr/>
           <a:lstStyle/>
           <a:p>
-            <a:pPr lvl="0" indent="0" marL="0">
+            <a:pPr marL="0" lvl="0" indent="0">
               <a:buNone/>
             </a:pPr>
             <a:r>
-              <a:rPr/>
               <a:t>WiFi：吞吐结果</a:t>
             </a:r>
           </a:p>
@@ -5191,7 +6053,7 @@
       </p:sp>
       <p:pic>
         <p:nvPicPr>
-          <p:cNvPr descr="assets/throughput.svg" id="0" name="Picture 1"/>
+          <p:cNvPr id="3" name="Picture 1" descr="figures/f4_throughput.png"/>
           <p:cNvPicPr>
             <a:picLocks noGrp="1" noChangeAspect="1"/>
           </p:cNvPicPr>
@@ -5205,8 +6067,8 @@
         </p:blipFill>
         <p:spPr bwMode="auto">
           <a:xfrm>
-            <a:off x="508000" y="1193800"/>
-            <a:ext cx="8140700" cy="3390900"/>
+            <a:off x="457200" y="1460500"/>
+            <a:ext cx="8229600" cy="2857500"/>
           </a:xfrm>
           <a:prstGeom prst="rect">
             <a:avLst/>
@@ -5221,6 +6083,9 @@
       </p:pic>
     </p:spTree>
   </p:cSld>
+  <p:clrMapOvr>
+    <a:masterClrMapping/>
+  </p:clrMapOvr>
 </p:sld>
 </file>
 
@@ -5542,265 +6407,4 @@
   </a:objectDefaults>
   <a:extraClrSchemeLst/>
 </a:theme>
-</file>
-
-<file path=ppt/theme/theme2.xml><?xml version="1.0" encoding="utf-8"?>
-<a:theme xmlns:a="http://schemas.openxmlformats.org/drawingml/2006/main" name="Office Theme">
-  <a:themeElements>
-    <a:clrScheme name="Office">
-      <a:dk1>
-        <a:sysClr val="windowText" lastClr="000000"/>
-      </a:dk1>
-      <a:lt1>
-        <a:sysClr val="window" lastClr="FFFFFF"/>
-      </a:lt1>
-      <a:dk2>
-        <a:srgbClr val="44546A"/>
-      </a:dk2>
-      <a:lt2>
-        <a:srgbClr val="E7E6E6"/>
-      </a:lt2>
-      <a:accent1>
-        <a:srgbClr val="5B9BD5"/>
-      </a:accent1>
-      <a:accent2>
-        <a:srgbClr val="ED7D31"/>
-      </a:accent2>
-      <a:accent3>
-        <a:srgbClr val="A5A5A5"/>
-      </a:accent3>
-      <a:accent4>
-        <a:srgbClr val="FFC000"/>
-      </a:accent4>
-      <a:accent5>
-        <a:srgbClr val="4472C4"/>
-      </a:accent5>
-      <a:accent6>
-        <a:srgbClr val="70AD47"/>
-      </a:accent6>
-      <a:hlink>
-        <a:srgbClr val="0563C1"/>
-      </a:hlink>
-      <a:folHlink>
-        <a:srgbClr val="954F72"/>
-      </a:folHlink>
-    </a:clrScheme>
-    <a:fontScheme name="Office">
-      <a:majorFont>
-        <a:latin typeface="Calibri Light" panose="020F0302020204030204"/>
-        <a:ea typeface=""/>
-        <a:cs typeface=""/>
-        <a:font script="Jpan" typeface="ＭＳ Ｐゴシック"/>
-        <a:font script="Hang" typeface="맑은 고딕"/>
-        <a:font script="Hans" typeface="宋体"/>
-        <a:font script="Hant" typeface="新細明體"/>
-        <a:font script="Arab" typeface="Times New Roman"/>
-        <a:font script="Hebr" typeface="Times New Roman"/>
-        <a:font script="Thai" typeface="Angsana New"/>
-        <a:font script="Ethi" typeface="Nyala"/>
-        <a:font script="Beng" typeface="Vrinda"/>
-        <a:font script="Gujr" typeface="Shruti"/>
-        <a:font script="Khmr" typeface="MoolBoran"/>
-        <a:font script="Knda" typeface="Tunga"/>
-        <a:font script="Guru" typeface="Raavi"/>
-        <a:font script="Cans" typeface="Euphemia"/>
-        <a:font script="Cher" typeface="Plantagenet Cherokee"/>
-        <a:font script="Yiii" typeface="Microsoft Yi Baiti"/>
-        <a:font script="Tibt" typeface="Microsoft Himalaya"/>
-        <a:font script="Thaa" typeface="MV Boli"/>
-        <a:font script="Deva" typeface="Mangal"/>
-        <a:font script="Telu" typeface="Gautami"/>
-        <a:font script="Taml" typeface="Latha"/>
-        <a:font script="Syrc" typeface="Estrangelo Edessa"/>
-        <a:font script="Orya" typeface="Kalinga"/>
-        <a:font script="Mlym" typeface="Kartika"/>
-        <a:font script="Laoo" typeface="DokChampa"/>
-        <a:font script="Sinh" typeface="Iskoola Pota"/>
-        <a:font script="Mong" typeface="Mongolian Baiti"/>
-        <a:font script="Viet" typeface="Times New Roman"/>
-        <a:font script="Uigh" typeface="Microsoft Uighur"/>
-        <a:font script="Geor" typeface="Sylfaen"/>
-      </a:majorFont>
-      <a:minorFont>
-        <a:latin typeface="Calibri" panose="020F0502020204030204"/>
-        <a:ea typeface=""/>
-        <a:cs typeface=""/>
-        <a:font script="Jpan" typeface="ＭＳ Ｐゴシック"/>
-        <a:font script="Hang" typeface="맑은 고딕"/>
-        <a:font script="Hans" typeface="宋体"/>
-        <a:font script="Hant" typeface="新細明體"/>
-        <a:font script="Arab" typeface="Arial"/>
-        <a:font script="Hebr" typeface="Arial"/>
-        <a:font script="Thai" typeface="Cordia New"/>
-        <a:font script="Ethi" typeface="Nyala"/>
-        <a:font script="Beng" typeface="Vrinda"/>
-        <a:font script="Gujr" typeface="Shruti"/>
-        <a:font script="Khmr" typeface="DaunPenh"/>
-        <a:font script="Knda" typeface="Tunga"/>
-        <a:font script="Guru" typeface="Raavi"/>
-        <a:font script="Cans" typeface="Euphemia"/>
-        <a:font script="Cher" typeface="Plantagenet Cherokee"/>
-        <a:font script="Yiii" typeface="Microsoft Yi Baiti"/>
-        <a:font script="Tibt" typeface="Microsoft Himalaya"/>
-        <a:font script="Thaa" typeface="MV Boli"/>
-        <a:font script="Deva" typeface="Mangal"/>
-        <a:font script="Telu" typeface="Gautami"/>
-        <a:font script="Taml" typeface="Latha"/>
-        <a:font script="Syrc" typeface="Estrangelo Edessa"/>
-        <a:font script="Orya" typeface="Kalinga"/>
-        <a:font script="Mlym" typeface="Kartika"/>
-        <a:font script="Laoo" typeface="DokChampa"/>
-        <a:font script="Sinh" typeface="Iskoola Pota"/>
-        <a:font script="Mong" typeface="Mongolian Baiti"/>
-        <a:font script="Viet" typeface="Arial"/>
-        <a:font script="Uigh" typeface="Microsoft Uighur"/>
-        <a:font script="Geor" typeface="Sylfaen"/>
-      </a:minorFont>
-    </a:fontScheme>
-    <a:fmtScheme name="Office">
-      <a:fillStyleLst>
-        <a:solidFill>
-          <a:schemeClr val="phClr"/>
-        </a:solidFill>
-        <a:gradFill rotWithShape="1">
-          <a:gsLst>
-            <a:gs pos="0">
-              <a:schemeClr val="phClr">
-                <a:lumMod val="110000"/>
-                <a:satMod val="105000"/>
-                <a:tint val="67000"/>
-              </a:schemeClr>
-            </a:gs>
-            <a:gs pos="50000">
-              <a:schemeClr val="phClr">
-                <a:lumMod val="105000"/>
-                <a:satMod val="103000"/>
-                <a:tint val="73000"/>
-              </a:schemeClr>
-            </a:gs>
-            <a:gs pos="100000">
-              <a:schemeClr val="phClr">
-                <a:lumMod val="105000"/>
-                <a:satMod val="109000"/>
-                <a:tint val="81000"/>
-              </a:schemeClr>
-            </a:gs>
-          </a:gsLst>
-          <a:lin ang="5400000" scaled="0"/>
-        </a:gradFill>
-        <a:gradFill rotWithShape="1">
-          <a:gsLst>
-            <a:gs pos="0">
-              <a:schemeClr val="phClr">
-                <a:satMod val="103000"/>
-                <a:lumMod val="102000"/>
-                <a:tint val="94000"/>
-              </a:schemeClr>
-            </a:gs>
-            <a:gs pos="50000">
-              <a:schemeClr val="phClr">
-                <a:satMod val="110000"/>
-                <a:lumMod val="100000"/>
-                <a:shade val="100000"/>
-              </a:schemeClr>
-            </a:gs>
-            <a:gs pos="100000">
-              <a:schemeClr val="phClr">
-                <a:lumMod val="99000"/>
-                <a:satMod val="120000"/>
-                <a:shade val="78000"/>
-              </a:schemeClr>
-            </a:gs>
-          </a:gsLst>
-          <a:lin ang="5400000" scaled="0"/>
-        </a:gradFill>
-      </a:fillStyleLst>
-      <a:lnStyleLst>
-        <a:ln w="6350" cap="flat" cmpd="sng" algn="ctr">
-          <a:solidFill>
-            <a:schemeClr val="phClr"/>
-          </a:solidFill>
-          <a:prstDash val="solid"/>
-          <a:miter lim="800000"/>
-        </a:ln>
-        <a:ln w="12700" cap="flat" cmpd="sng" algn="ctr">
-          <a:solidFill>
-            <a:schemeClr val="phClr"/>
-          </a:solidFill>
-          <a:prstDash val="solid"/>
-          <a:miter lim="800000"/>
-        </a:ln>
-        <a:ln w="19050" cap="flat" cmpd="sng" algn="ctr">
-          <a:solidFill>
-            <a:schemeClr val="phClr"/>
-          </a:solidFill>
-          <a:prstDash val="solid"/>
-          <a:miter lim="800000"/>
-        </a:ln>
-      </a:lnStyleLst>
-      <a:effectStyleLst>
-        <a:effectStyle>
-          <a:effectLst/>
-        </a:effectStyle>
-        <a:effectStyle>
-          <a:effectLst/>
-        </a:effectStyle>
-        <a:effectStyle>
-          <a:effectLst>
-            <a:outerShdw blurRad="57150" dist="19050" dir="5400000" algn="ctr" rotWithShape="0">
-              <a:srgbClr val="000000">
-                <a:alpha val="63000"/>
-              </a:srgbClr>
-            </a:outerShdw>
-          </a:effectLst>
-        </a:effectStyle>
-      </a:effectStyleLst>
-      <a:bgFillStyleLst>
-        <a:solidFill>
-          <a:schemeClr val="phClr"/>
-        </a:solidFill>
-        <a:solidFill>
-          <a:schemeClr val="phClr">
-            <a:tint val="95000"/>
-            <a:satMod val="170000"/>
-          </a:schemeClr>
-        </a:solidFill>
-        <a:gradFill rotWithShape="1">
-          <a:gsLst>
-            <a:gs pos="0">
-              <a:schemeClr val="phClr">
-                <a:tint val="93000"/>
-                <a:satMod val="150000"/>
-                <a:shade val="98000"/>
-                <a:lumMod val="102000"/>
-              </a:schemeClr>
-            </a:gs>
-            <a:gs pos="50000">
-              <a:schemeClr val="phClr">
-                <a:tint val="98000"/>
-                <a:satMod val="130000"/>
-                <a:shade val="90000"/>
-                <a:lumMod val="103000"/>
-              </a:schemeClr>
-            </a:gs>
-            <a:gs pos="100000">
-              <a:schemeClr val="phClr">
-                <a:shade val="63000"/>
-                <a:satMod val="120000"/>
-              </a:schemeClr>
-            </a:gs>
-          </a:gsLst>
-          <a:lin ang="5400000" scaled="0"/>
-        </a:gradFill>
-      </a:bgFillStyleLst>
-    </a:fmtScheme>
-  </a:themeElements>
-  <a:objectDefaults/>
-  <a:extraClrSchemeLst/>
-  <a:extLst>
-    <a:ext uri="{05A4C25C-085E-4340-85A3-A5531E510DB2}">
-      <thm15:themeFamily xmlns:thm15="http://schemas.microsoft.com/office/thememl/2012/main" name="Office Theme" id="{62F939B6-93AF-4DB8-9C6B-D6C7DFDC589F}" vid="{4A3C46E8-61CC-4603-A589-7422A47A8E4A}"/>
-    </a:ext>
-  </a:extLst>
-</a:theme>
 </file>
</xml_diff>